<commit_message>
Add the VZP app as a direct channel to interventions and system deck
interventions.md gets a section on the app as a two-way channel: one-tap
confirmation of a pre-booked slot, a barrier questionnaire with a
tailored next step, a prevention overview, feedback back to VZP, and the
caveats (self-selection, survey bias and fatigue, consent). Item 15
(push alone) now points to it.

The system deck gets a slide "Aplikace VZP: přímý kanál a zpětná vazba",
and the architecture slide lists the app and questionnaire answers.

Co-Authored-By: Claude Opus 5.5 <noreply@anthropic.com>
</commit_message>
<xml_diff>
--- a/docs/vzp_system/system.pptx
+++ b/docs/vzp_system/system.pptx
@@ -10,9 +10,10 @@
     <p:sldId id="258" r:id="rId4"/>
     <p:sldId id="259" r:id="rId5"/>
     <p:sldId id="260" r:id="rId6"/>
+    <p:sldId id="261" r:id="rId7"/>
   </p:sldIdLst>
   <p:notesMasterIdLst>
-    <p:notesMasterId r:id="rId7"/>
+    <p:notesMasterId r:id="rId8"/>
   </p:notesMasterIdLst>
   <p:sldSz cx="12192000" cy="6858000"/>
   <p:notesSz cx="6858000" cy="12192000"/>
@@ -111,25 +112,26 @@
   <p:extLst>
     <p:ext uri="{521415D9-36F7-43E2-AB2F-B90AF26B5E84}">
       <p14:sectionLst xmlns:p14="http://schemas.microsoft.com/office/powerpoint/2010/main">
-        <p14:section name="Úvod" id="{e3732e6e-0a1d-990b-4483-64f947943fa6}">
+        <p14:section name="Úvod" id="{7d13b6b6-503a-fd8e-90cc-d8429efe474d}">
           <p14:sldIdLst>
             <p14:sldId id="256"/>
           </p14:sldIdLst>
         </p14:section>
-        <p14:section name="Systém" id="{4c08f91b-81ca-82cf-43f8-951d61dbbded}">
+        <p14:section name="Systém" id="{072ea87d-3cbf-19db-522b-6a1439bb8857}">
           <p14:sldIdLst>
             <p14:sldId id="257"/>
+            <p14:sldId id="258"/>
           </p14:sldIdLst>
         </p14:section>
-        <p14:section name="Modely" id="{8c3d65c7-fdcb-3dc2-cecd-7b7dc24199fc}">
+        <p14:section name="Modely" id="{bcba3d1a-9736-a66e-73e4-8d9460f88542}">
           <p14:sldIdLst>
-            <p14:sldId id="258"/>
             <p14:sldId id="259"/>
+            <p14:sldId id="260"/>
           </p14:sldIdLst>
         </p14:section>
-        <p14:section name="Postup" id="{da8fab57-4322-9ef2-7a3c-382f38c73f2c}">
+        <p14:section name="Postup" id="{64e9d533-d177-ab67-653b-eee3c3846fd7}">
           <p14:sldIdLst>
-            <p14:sldId id="260"/>
+            <p14:sldId id="261"/>
           </p14:sldIdLst>
         </p14:section>
       </p14:sectionLst>
@@ -1704,7 +1706,7 @@
           <a:p>
             <a:r>
               <a:rPr lang="en-US" dirty="0"/>
-              <a:t>Pro pravděpodobnost účasti doporučuji Explainable Boosting Machine (InterpretML): zobecněný aditivní model s vybranými dvojicovými interakcemi, učený boostingem. Každý znak má vlastní křivku, kterou lze číst, ověřit s lékaři a případně upravit. Predikce jednoho klienta se přesně rozloží na příspěvky znaků. Přesnost bývá blízko gradient boostingu a pravděpodobnosti jsou dobře kalibrované, což potřebuje optimalizace i ekonomika. Lze vynutit monotónnost (čím déle od poslední prevence, tím nižší pravděpodobnost) a zkontrolovat férovost. Pro různé horizonty (3, 6, 12 měsíců) buď jeden model na horizont, nebo diskrétní model v čase. GBM se SHAP necháváme jako měřítko: ukáže, kolik přesnosti nás vysvětlitelnost stojí. Křivky na snímku jsou ilustrativní, ne z dat.</a:t>
+              <a:t>Aplikace VZP má mezi klienty dobrý dosah (zhruba 700 tisíc uživatelů; aktivita a podíl v cílových skupinách zatím nejsou známé) a VZP ji chce rozvíjet jako přímý kanál včetně zpětné vazby. Samotná push notifikace je slabá intervence: ve studii ze Singapuru na ni kliklo jen 4 % adresátek. Hodnota aplikace je jinde. Zaprvé jako levný kanál pro intervence, které fungují: předrezervovaný termín, který klient jedním klepnutím potvrdí, přesune nebo uvolní (uvolněné termíny se vracejí poskytovateli, což snižuje hlavní náklad předrezervace); dotazník bariér, podle jehož odpovědi následuje cílený krok (navigace telefonem jen tam, kde ji telefonát vyřeší); přehled všech preventivních programů na jednom místě; levné varianty zpráv. Zadruhé jako zdroj zpětné vazby: důvody neúčasti jako znaky pro model upliftu, zkušenost po vyšetření pro sledování kvality, dosažitelnost kanálů a platforma pro průběžné randomizované pokusy. Pozor na samovýběr uživatelů, zkreslení a únavu z dotazníků a na souhlas s využitím odpovědí.</a:t>
             </a:r>
             <a:endParaRPr lang="en-US" dirty="0"/>
           </a:p>
@@ -1792,8 +1794,7 @@
           <a:p>
             <a:r>
               <a:rPr lang="en-US" dirty="0"/>
-              <a:t>Klíčové omezení: bohatá data VZP (roky vykázané péče, diagnózy, léky, registrace, historie prevence, dřívější pozvánky a odezvy, dosažitelnost kanálů, region) dobře předpovídají, kdo přijde. Neřeknou ale, kdo přijde díky intervenci, protože kanály nebyly přidělované náhodně. Uplift naučený jen z historie by byl zkreslený.
-Proto: (1) každá kampaň randomizuje a zaznamenává pravděpodobnost přiřazení; trvalý podíl průzkumu (např. 10 %) a Thompson sampling; libovolné pravidlo cílení lze pak vyhodnotit offline. (2) Jádrem je bayesovský hierarchický model na škále logitu: f(x) je logit z modelu účasti (EBM) jako pevný offset a prior, β_k průměrný účinek intervence s priorem z literatury, g_k(x) rozdíly mezi klienty na stejných znacích jako EBM, smrštěné k nule (horseshoe, částečné sdílení). Před prvním pokusem je prior upliftu plně dán EBM a literaturou; každý pokus posune posterior. Uplift zůstává vysvětlitelný. (3) Až bude randomizovaných dat dost: víceramenný DR-learner na gradient boostingu (EBM jako model kontrolního ramene), causal forest pro intervaly spolehlivosti, při velkých datech vícehlavá neuronová síť. (4) Cílí se na zdravotní hodnotu, ne na samotnou účast: τ_k(x) krát zdravotní přínos vyšetření pro daného klienta minus náklad, v mezích rozpočtu, kapacit a rovnosti. (5) Vyhodnocení: Qini / AUUC, kalibrace upliftu, DR off-policy hodnota pravidla, trvalá kontrolní skupina. (6) Rizika: negativní uplift, pořadí a kombinace kanálů (později dynamický režim / kontextový bandit), posun v čase, férovost.</a:t>
+              <a:t>Pro pravděpodobnost účasti doporučuji Explainable Boosting Machine (InterpretML): zobecněný aditivní model s vybranými dvojicovými interakcemi, učený boostingem. Každý znak má vlastní křivku, kterou lze číst, ověřit s lékaři a případně upravit. Predikce jednoho klienta se přesně rozloží na příspěvky znaků. Přesnost bývá blízko gradient boostingu a pravděpodobnosti jsou dobře kalibrované, což potřebuje optimalizace i ekonomika. Lze vynutit monotónnost (čím déle od poslední prevence, tím nižší pravděpodobnost) a zkontrolovat férovost. Pro různé horizonty (3, 6, 12 měsíců) buď jeden model na horizont, nebo diskrétní model v čase. GBM se SHAP necháváme jako měřítko: ukáže, kolik přesnosti nás vysvětlitelnost stojí. Křivky na snímku jsou ilustrativní, ne z dat.</a:t>
             </a:r>
             <a:endParaRPr lang="en-US" dirty="0"/>
           </a:p>
@@ -1881,7 +1882,8 @@
           <a:p>
             <a:r>
               <a:rPr lang="en-US" dirty="0"/>
-              <a:t>Začneme s tím, co máme: model účasti z historických dat a účinky intervencí z literatury. Pilotní pokus s několika rameny po segmentech dá první posterior. Pak cílíme podle zdravotní hodnoty, s trvalým průzkumem a kontrolní skupinou, a model pravidelně přeučujeme. Monitoring sleduje provoz, ekonomiku a zdravotní výsledky od začátku.</a:t>
+              <a:t>Klíčové omezení: bohatá data VZP (roky vykázané péče, diagnózy, léky, registrace, historie prevence, dřívější pozvánky a odezvy, dosažitelnost kanálů, region) dobře předpovídají, kdo přijde. Neřeknou ale, kdo přijde díky intervenci, protože kanály nebyly přidělované náhodně. Uplift naučený jen z historie by byl zkreslený.
+Proto: (1) každá kampaň randomizuje a zaznamenává pravděpodobnost přiřazení; trvalý podíl průzkumu (např. 10 %) a Thompson sampling; libovolné pravidlo cílení lze pak vyhodnotit offline. (2) Jádrem je bayesovský hierarchický model na škále logitu: f(x) je logit z modelu účasti (EBM) jako pevný offset a prior, β_k průměrný účinek intervence s priorem z literatury, g_k(x) rozdíly mezi klienty na stejných znacích jako EBM, smrštěné k nule (horseshoe, částečné sdílení). Před prvním pokusem je prior upliftu plně dán EBM a literaturou; každý pokus posune posterior. Uplift zůstává vysvětlitelný. (3) Až bude randomizovaných dat dost: víceramenný DR-learner na gradient boostingu (EBM jako model kontrolního ramene), causal forest pro intervaly spolehlivosti, při velkých datech vícehlavá neuronová síť. (4) Cílí se na zdravotní hodnotu, ne na samotnou účast: τ_k(x) krát zdravotní přínos vyšetření pro daného klienta minus náklad, v mezích rozpočtu, kapacit a rovnosti. (5) Vyhodnocení: Qini / AUUC, kalibrace upliftu, DR off-policy hodnota pravidla, trvalá kontrolní skupina. (6) Rizika: negativní uplift, pořadí a kombinace kanálů (později dynamický režim / kontextový bandit), posun v čase, férovost.</a:t>
             </a:r>
             <a:endParaRPr lang="en-US" dirty="0"/>
           </a:p>
@@ -1905,6 +1907,94 @@
             <a:fld id="{F7021451-1387-4CA6-816F-3879F97B5CBC}" type="slidenum">
               <a:rPr lang="en-US"/>
               <a:t>5</a:t>
+            </a:fld>
+            <a:endParaRPr lang="en-US"/>
+          </a:p>
+        </p:txBody>
+      </p:sp>
+    </p:spTree>
+    <p:extLst>
+      <p:ext uri="{BB962C8B-B14F-4D97-AF65-F5344CB8AC3E}">
+        <p14:creationId xmlns:p14="http://schemas.microsoft.com/office/powerpoint/2010/main" val="1024086991"/>
+      </p:ext>
+    </p:extLst>
+  </p:cSld>
+  <p:clrMapOvr>
+    <a:masterClrMapping/>
+  </p:clrMapOvr>
+</p:notes>
+</file>
+
+<file path=ppt/notesSlides/notesSlide6.xml><?xml version="1.0" encoding="utf-8"?>
+<p:notes xmlns:a="http://schemas.openxmlformats.org/drawingml/2006/main" xmlns:r="http://schemas.openxmlformats.org/officeDocument/2006/relationships" xmlns:p="http://schemas.openxmlformats.org/presentationml/2006/main">
+  <p:cSld>
+    <p:spTree>
+      <p:nvGrpSpPr>
+        <p:cNvPr id="1" name=""/>
+        <p:cNvGrpSpPr/>
+        <p:nvPr/>
+      </p:nvGrpSpPr>
+      <p:grpSpPr>
+        <a:xfrm>
+          <a:off x="0" y="0"/>
+          <a:ext cx="0" cy="0"/>
+          <a:chOff x="0" y="0"/>
+          <a:chExt cx="0" cy="0"/>
+        </a:xfrm>
+      </p:grpSpPr>
+      <p:sp>
+        <p:nvSpPr>
+          <p:cNvPr id="2" name="Slide Image Placeholder 1"/>
+          <p:cNvSpPr>
+            <a:spLocks noGrp="1" noRot="1" noChangeAspect="1"/>
+          </p:cNvSpPr>
+          <p:nvPr>
+            <p:ph type="sldImg"/>
+          </p:nvPr>
+        </p:nvSpPr>
+        <p:spPr/>
+      </p:sp>
+      <p:sp>
+        <p:nvSpPr>
+          <p:cNvPr id="3" name="Notes Placeholder 2"/>
+          <p:cNvSpPr>
+            <a:spLocks noGrp="1"/>
+          </p:cNvSpPr>
+          <p:nvPr>
+            <p:ph type="body" idx="1"/>
+          </p:nvPr>
+        </p:nvSpPr>
+        <p:spPr/>
+        <p:txBody>
+          <a:bodyPr/>
+          <a:lstStyle/>
+          <a:p>
+            <a:r>
+              <a:rPr lang="en-US" dirty="0"/>
+              <a:t>Začneme s tím, co máme: model účasti z historických dat a účinky intervencí z literatury. Pilotní pokus s několika rameny po segmentech dá první posterior. Pak cílíme podle zdravotní hodnoty, s trvalým průzkumem a kontrolní skupinou, a model pravidelně přeučujeme. Monitoring sleduje provoz, ekonomiku a zdravotní výsledky od začátku.</a:t>
+            </a:r>
+            <a:endParaRPr lang="en-US" dirty="0"/>
+          </a:p>
+        </p:txBody>
+      </p:sp>
+      <p:sp>
+        <p:nvSpPr>
+          <p:cNvPr id="4" name="Slide Number Placeholder 3"/>
+          <p:cNvSpPr>
+            <a:spLocks noGrp="1"/>
+          </p:cNvSpPr>
+          <p:nvPr>
+            <p:ph type="sldNum" sz="quarter" idx="10"/>
+          </p:nvPr>
+        </p:nvSpPr>
+        <p:spPr/>
+        <p:txBody>
+          <a:bodyPr/>
+          <a:lstStyle/>
+          <a:p>
+            <a:fld id="{F7021451-1387-4CA6-816F-3879F97B5CBC}" type="slidenum">
+              <a:rPr lang="en-US"/>
+              <a:t>6</a:t>
             </a:fld>
             <a:endParaRPr lang="en-US"/>
           </a:p>
@@ -3334,7 +3424,7 @@
                   <a:schemeClr val="tx1"/>
                 </a:solidFill>
               </a:rPr>
-              <a:t> dopis, e-mail, push notifikace, SMS, telefonát / navigace, předrezervovaný termín</a:t>
+              <a:t> dopis, e-mail, aplikace VZP (push, rezervace), SMS, telefonát / navigace, předrezervovaný termín</a:t>
             </a:r>
             <a:endParaRPr lang="en-US" sz="1700" dirty="0"/>
           </a:p>
@@ -3359,7 +3449,7 @@
                   <a:schemeClr val="tx1"/>
                 </a:solidFill>
               </a:rPr>
-              <a:t> odezva, rezervace termínu, odhlášení a preference kanálu</a:t>
+              <a:t> odezva, rezervace termínu, odhlášení, preference kanálu, odpovědi v dotaznících</a:t>
             </a:r>
             <a:endParaRPr lang="en-US" sz="1700" dirty="0"/>
           </a:p>
@@ -4278,7 +4368,7 @@
                   <a:schemeClr val="accent1"/>
                 </a:solidFill>
               </a:rPr>
-              <a:t>Model pravděpodobnosti účasti: vysvětlitelný (EBM)</a:t>
+              <a:t>Aplikace VZP: přímý kanál a zpětná vazba</a:t>
             </a:r>
             <a:endParaRPr lang="en-US" sz="3000" dirty="0"/>
           </a:p>
@@ -4286,228 +4376,54 @@
       </p:sp>
       <p:sp>
         <p:nvSpPr>
-          <p:cNvPr id="3" name="vzorec"/>
+          <p:cNvPr id="3" name="dorucit_nadpis"/>
+          <p:cNvSpPr txBox="1"/>
+          <p:nvPr/>
+        </p:nvSpPr>
+        <p:spPr>
+          <a:xfrm>
+            <a:off x="548640" y="1234440"/>
+            <a:ext cx="6446520" cy="320040"/>
+          </a:xfrm>
+          <a:prstGeom prst="rect">
+            <a:avLst/>
+          </a:prstGeom>
+          <a:noFill/>
+          <a:ln/>
+        </p:spPr>
+        <p:txBody>
+          <a:bodyPr wrap="square" lIns="0" tIns="0" rIns="0" bIns="0" rtlCol="0" anchor="t"/>
+          <a:lstStyle/>
+          <a:p>
+            <a:pPr indent="0" marL="0">
+              <a:buNone/>
+            </a:pPr>
+            <a:r>
+              <a:rPr lang="en-US" sz="1600" b="1" dirty="0">
+                <a:solidFill>
+                  <a:schemeClr val="accent1"/>
+                </a:solidFill>
+              </a:rPr>
+              <a:t>Co aplikace doručí</a:t>
+            </a:r>
+            <a:endParaRPr lang="en-US" sz="1600" dirty="0"/>
+          </a:p>
+        </p:txBody>
+      </p:sp>
+      <p:sp>
+        <p:nvSpPr>
+          <p:cNvPr id="4" name="aplikace_1"/>
           <p:cNvSpPr/>
           <p:nvPr/>
         </p:nvSpPr>
         <p:spPr>
           <a:xfrm>
-            <a:off x="548640" y="1234440"/>
-            <a:ext cx="11094415" cy="640080"/>
+            <a:off x="548640" y="1691640"/>
+            <a:ext cx="3108960" cy="1554480"/>
           </a:xfrm>
           <a:prstGeom prst="roundRect">
             <a:avLst>
-              <a:gd name="adj" fmla="val 11429"/>
-            </a:avLst>
-          </a:prstGeom>
-          <a:solidFill>
-            <a:schemeClr val="accent1"/>
-          </a:solidFill>
-          <a:ln/>
-        </p:spPr>
-      </p:sp>
-      <p:sp>
-        <p:nvSpPr>
-          <p:cNvPr id="4" name="vzorec_text"/>
-          <p:cNvSpPr txBox="1"/>
-          <p:nvPr/>
-        </p:nvSpPr>
-        <p:spPr>
-          <a:xfrm>
-            <a:off x="777240" y="1325880"/>
-            <a:ext cx="10637215" cy="457200"/>
-          </a:xfrm>
-          <a:prstGeom prst="rect">
-            <a:avLst/>
-          </a:prstGeom>
-          <a:noFill/>
-          <a:ln/>
-        </p:spPr>
-        <p:txBody>
-          <a:bodyPr wrap="square" lIns="0" tIns="0" rIns="0" bIns="0" rtlCol="0" anchor="ctr"/>
-          <a:lstStyle/>
-          <a:p>
-            <a:pPr indent="0" marL="0">
-              <a:buNone/>
-            </a:pPr>
-            <a:r>
-              <a:rPr lang="en-US" sz="1800" dirty="0">
-                <a:solidFill>
-                  <a:schemeClr val="bg1"/>
-                </a:solidFill>
-              </a:rPr>
-              <a:t>logit p(x) = β</a:t>
-            </a:r>
-            <a:r>
-              <a:rPr lang="en-US" sz="1800" baseline="-40000" dirty="0">
-                <a:solidFill>
-                  <a:schemeClr val="bg1"/>
-                </a:solidFill>
-              </a:rPr>
-              <a:t>0</a:t>
-            </a:r>
-            <a:r>
-              <a:rPr lang="en-US" sz="1800" dirty="0">
-                <a:solidFill>
-                  <a:schemeClr val="bg1"/>
-                </a:solidFill>
-              </a:rPr>
-              <a:t> + Σ f</a:t>
-            </a:r>
-            <a:r>
-              <a:rPr lang="en-US" sz="1800" baseline="-40000" dirty="0">
-                <a:solidFill>
-                  <a:schemeClr val="bg1"/>
-                </a:solidFill>
-              </a:rPr>
-              <a:t>j</a:t>
-            </a:r>
-            <a:r>
-              <a:rPr lang="en-US" sz="1800" dirty="0">
-                <a:solidFill>
-                  <a:schemeClr val="bg1"/>
-                </a:solidFill>
-              </a:rPr>
-              <a:t>(x</a:t>
-            </a:r>
-            <a:r>
-              <a:rPr lang="en-US" sz="1800" baseline="-40000" dirty="0">
-                <a:solidFill>
-                  <a:schemeClr val="bg1"/>
-                </a:solidFill>
-              </a:rPr>
-              <a:t>j</a:t>
-            </a:r>
-            <a:r>
-              <a:rPr lang="en-US" sz="1800" dirty="0">
-                <a:solidFill>
-                  <a:schemeClr val="bg1"/>
-                </a:solidFill>
-              </a:rPr>
-              <a:t>) + Σ f</a:t>
-            </a:r>
-            <a:r>
-              <a:rPr lang="en-US" sz="1800" baseline="-40000" dirty="0">
-                <a:solidFill>
-                  <a:schemeClr val="bg1"/>
-                </a:solidFill>
-              </a:rPr>
-              <a:t>ij</a:t>
-            </a:r>
-            <a:r>
-              <a:rPr lang="en-US" sz="1800" dirty="0">
-                <a:solidFill>
-                  <a:schemeClr val="bg1"/>
-                </a:solidFill>
-              </a:rPr>
-              <a:t>(x</a:t>
-            </a:r>
-            <a:r>
-              <a:rPr lang="en-US" sz="1800" baseline="-40000" dirty="0">
-                <a:solidFill>
-                  <a:schemeClr val="bg1"/>
-                </a:solidFill>
-              </a:rPr>
-              <a:t>i</a:t>
-            </a:r>
-            <a:r>
-              <a:rPr lang="en-US" sz="1800" dirty="0">
-                <a:solidFill>
-                  <a:schemeClr val="bg1"/>
-                </a:solidFill>
-              </a:rPr>
-              <a:t>, x</a:t>
-            </a:r>
-            <a:r>
-              <a:rPr lang="en-US" sz="1800" baseline="-40000" dirty="0">
-                <a:solidFill>
-                  <a:schemeClr val="bg1"/>
-                </a:solidFill>
-              </a:rPr>
-              <a:t>j</a:t>
-            </a:r>
-            <a:r>
-              <a:rPr lang="en-US" sz="1800" dirty="0">
-                <a:solidFill>
-                  <a:schemeClr val="bg1"/>
-                </a:solidFill>
-              </a:rPr>
-              <a:t>)</a:t>
-            </a:r>
-            <a:r>
-              <a:rPr lang="en-US" sz="1300" dirty="0">
-                <a:solidFill>
-                  <a:schemeClr val="accent3"/>
-                </a:solidFill>
-              </a:rPr>
-              <a:t>     Explainable Boosting Machine: zobecněný aditivní model s vybranými interakcemi, učený boostingem</a:t>
-            </a:r>
-            <a:endParaRPr lang="en-US" sz="1800" dirty="0"/>
-          </a:p>
-        </p:txBody>
-      </p:sp>
-      <p:graphicFrame>
-        <p:nvGraphicFramePr>
-          <p:cNvPr id="5" name="tvarova_funkce_1" descr=""/>
-          <p:cNvGraphicFramePr/>
-          <p:nvPr/>
-        </p:nvGraphicFramePr>
-        <p:xfrm>
-          <a:off x="548640" y="2103120"/>
-          <a:ext cx="2788920" cy="1965960"/>
-        </p:xfrm>
-        <a:graphic xmlns:a="http://schemas.openxmlformats.org/drawingml/2006/main">
-          <a:graphicData uri="http://schemas.openxmlformats.org/drawingml/2006/chart">
-            <c:chart xmlns:c="http://schemas.openxmlformats.org/drawingml/2006/chart" r:id="rId1"/>
-          </a:graphicData>
-        </a:graphic>
-      </p:graphicFrame>
-      <p:graphicFrame>
-        <p:nvGraphicFramePr>
-          <p:cNvPr id="6" name="tvarova_funkce_2" descr=""/>
-          <p:cNvGraphicFramePr/>
-          <p:nvPr/>
-        </p:nvGraphicFramePr>
-        <p:xfrm>
-          <a:off x="3520440" y="2103120"/>
-          <a:ext cx="2788920" cy="1965960"/>
-        </p:xfrm>
-        <a:graphic xmlns:a="http://schemas.openxmlformats.org/drawingml/2006/main">
-          <a:graphicData uri="http://schemas.openxmlformats.org/drawingml/2006/chart">
-            <c:chart xmlns:c="http://schemas.openxmlformats.org/drawingml/2006/chart" r:id="rId2"/>
-          </a:graphicData>
-        </a:graphic>
-      </p:graphicFrame>
-      <p:graphicFrame>
-        <p:nvGraphicFramePr>
-          <p:cNvPr id="7" name="tvarova_funkce_3" descr=""/>
-          <p:cNvGraphicFramePr/>
-          <p:nvPr/>
-        </p:nvGraphicFramePr>
-        <p:xfrm>
-          <a:off x="548640" y="4251960"/>
-          <a:ext cx="2788920" cy="1965960"/>
-        </p:xfrm>
-        <a:graphic xmlns:a="http://schemas.openxmlformats.org/drawingml/2006/main">
-          <a:graphicData uri="http://schemas.openxmlformats.org/drawingml/2006/chart">
-            <c:chart xmlns:c="http://schemas.openxmlformats.org/drawingml/2006/chart" r:id="rId3"/>
-          </a:graphicData>
-        </a:graphic>
-      </p:graphicFrame>
-      <p:sp>
-        <p:nvSpPr>
-          <p:cNvPr id="8" name="jak_cist"/>
-          <p:cNvSpPr/>
-          <p:nvPr/>
-        </p:nvSpPr>
-        <p:spPr>
-          <a:xfrm>
-            <a:off x="3520440" y="4251960"/>
-            <a:ext cx="2788920" cy="1965960"/>
-          </a:xfrm>
-          <a:prstGeom prst="roundRect">
-            <a:avLst>
-              <a:gd name="adj" fmla="val 3721"/>
+              <a:gd name="adj" fmla="val 4706"/>
             </a:avLst>
           </a:prstGeom>
           <a:solidFill>
@@ -4518,14 +4434,73 @@
       </p:sp>
       <p:sp>
         <p:nvSpPr>
-          <p:cNvPr id="9" name="jak_cist_text"/>
+          <p:cNvPr id="5" name="aplikace_1_cislo"/>
+          <p:cNvSpPr/>
+          <p:nvPr/>
+        </p:nvSpPr>
+        <p:spPr>
+          <a:xfrm>
+            <a:off x="731520" y="1874520"/>
+            <a:ext cx="457200" cy="457200"/>
+          </a:xfrm>
+          <a:prstGeom prst="ellipse">
+            <a:avLst/>
+          </a:prstGeom>
+          <a:solidFill>
+            <a:schemeClr val="accent2"/>
+          </a:solidFill>
+          <a:ln/>
+        </p:spPr>
+      </p:sp>
+      <p:sp>
+        <p:nvSpPr>
+          <p:cNvPr id="6" name="aplikace_1_cislo_text"/>
           <p:cNvSpPr txBox="1"/>
           <p:nvPr/>
         </p:nvSpPr>
         <p:spPr>
           <a:xfrm>
-            <a:off x="3685032" y="4383634"/>
-            <a:ext cx="2459736" cy="1702613"/>
+            <a:off x="731520" y="1874520"/>
+            <a:ext cx="457200" cy="457200"/>
+          </a:xfrm>
+          <a:prstGeom prst="rect">
+            <a:avLst/>
+          </a:prstGeom>
+          <a:noFill/>
+          <a:ln/>
+        </p:spPr>
+        <p:txBody>
+          <a:bodyPr wrap="square" lIns="0" tIns="0" rIns="0" bIns="0" rtlCol="0" anchor="ctr"/>
+          <a:lstStyle/>
+          <a:p>
+            <a:pPr algn="ctr" indent="0" marL="0">
+              <a:buNone/>
+            </a:pPr>
+            <a:r>
+              <a:rPr lang="en-US" sz="1600" b="1" dirty="0">
+                <a:solidFill>
+                  <a:schemeClr val="bg1"/>
+                </a:solidFill>
+                <a:latin typeface="Cambria" pitchFamily="34" charset="0"/>
+                <a:ea typeface="Cambria" pitchFamily="34" charset="-122"/>
+                <a:cs typeface="Cambria" pitchFamily="34" charset="-120"/>
+              </a:rPr>
+              <a:t>1</a:t>
+            </a:r>
+            <a:endParaRPr lang="en-US" sz="1600" dirty="0"/>
+          </a:p>
+        </p:txBody>
+      </p:sp>
+      <p:sp>
+        <p:nvSpPr>
+          <p:cNvPr id="7" name="aplikace_1_text"/>
+          <p:cNvSpPr txBox="1"/>
+          <p:nvPr/>
+        </p:nvSpPr>
+        <p:spPr>
+          <a:xfrm>
+            <a:off x="1325880" y="1874520"/>
+            <a:ext cx="2148840" cy="1234440"/>
           </a:xfrm>
           <a:prstGeom prst="rect">
             <a:avLst/>
@@ -4549,7 +4524,7 @@
                   <a:schemeClr val="accent1"/>
                 </a:solidFill>
               </a:rPr>
-              <a:t>Jak číst</a:t>
+              <a:t>Rezervace jedním klepnutím</a:t>
             </a:r>
             <a:endParaRPr lang="en-US" sz="1500" dirty="0"/>
           </a:p>
@@ -4558,44 +4533,414 @@
               <a:buNone/>
             </a:pPr>
             <a:r>
-              <a:rPr lang="en-US" sz="1200" dirty="0">
+              <a:rPr lang="en-US" sz="1300" dirty="0">
                 <a:solidFill>
                   <a:schemeClr val="tx1"/>
                 </a:solidFill>
               </a:rPr>
-              <a:t>Každá křivka je </a:t>
-            </a:r>
-            <a:r>
-              <a:rPr lang="en-US" sz="1200" b="1" dirty="0">
+              <a:t>předrezervovaný termín: potvrdit, přesunout, uvolnit; uvolněné termíny se vrací poskytovateli</a:t>
+            </a:r>
+            <a:endParaRPr lang="en-US" sz="1500" dirty="0"/>
+          </a:p>
+        </p:txBody>
+      </p:sp>
+      <p:sp>
+        <p:nvSpPr>
+          <p:cNvPr id="8" name="aplikace_2"/>
+          <p:cNvSpPr/>
+          <p:nvPr/>
+        </p:nvSpPr>
+        <p:spPr>
+          <a:xfrm>
+            <a:off x="3886200" y="1691640"/>
+            <a:ext cx="3108960" cy="1554480"/>
+          </a:xfrm>
+          <a:prstGeom prst="roundRect">
+            <a:avLst>
+              <a:gd name="adj" fmla="val 4706"/>
+            </a:avLst>
+          </a:prstGeom>
+          <a:solidFill>
+            <a:schemeClr val="bg2"/>
+          </a:solidFill>
+          <a:ln/>
+        </p:spPr>
+      </p:sp>
+      <p:sp>
+        <p:nvSpPr>
+          <p:cNvPr id="9" name="aplikace_2_cislo"/>
+          <p:cNvSpPr/>
+          <p:nvPr/>
+        </p:nvSpPr>
+        <p:spPr>
+          <a:xfrm>
+            <a:off x="4069080" y="1874520"/>
+            <a:ext cx="457200" cy="457200"/>
+          </a:xfrm>
+          <a:prstGeom prst="ellipse">
+            <a:avLst/>
+          </a:prstGeom>
+          <a:solidFill>
+            <a:schemeClr val="accent2"/>
+          </a:solidFill>
+          <a:ln/>
+        </p:spPr>
+      </p:sp>
+      <p:sp>
+        <p:nvSpPr>
+          <p:cNvPr id="10" name="aplikace_2_cislo_text"/>
+          <p:cNvSpPr txBox="1"/>
+          <p:nvPr/>
+        </p:nvSpPr>
+        <p:spPr>
+          <a:xfrm>
+            <a:off x="4069080" y="1874520"/>
+            <a:ext cx="457200" cy="457200"/>
+          </a:xfrm>
+          <a:prstGeom prst="rect">
+            <a:avLst/>
+          </a:prstGeom>
+          <a:noFill/>
+          <a:ln/>
+        </p:spPr>
+        <p:txBody>
+          <a:bodyPr wrap="square" lIns="0" tIns="0" rIns="0" bIns="0" rtlCol="0" anchor="ctr"/>
+          <a:lstStyle/>
+          <a:p>
+            <a:pPr algn="ctr" indent="0" marL="0">
+              <a:buNone/>
+            </a:pPr>
+            <a:r>
+              <a:rPr lang="en-US" sz="1600" b="1" dirty="0">
+                <a:solidFill>
+                  <a:schemeClr val="bg1"/>
+                </a:solidFill>
+                <a:latin typeface="Cambria" pitchFamily="34" charset="0"/>
+                <a:ea typeface="Cambria" pitchFamily="34" charset="-122"/>
+                <a:cs typeface="Cambria" pitchFamily="34" charset="-120"/>
+              </a:rPr>
+              <a:t>2</a:t>
+            </a:r>
+            <a:endParaRPr lang="en-US" sz="1600" dirty="0"/>
+          </a:p>
+        </p:txBody>
+      </p:sp>
+      <p:sp>
+        <p:nvSpPr>
+          <p:cNvPr id="11" name="aplikace_2_text"/>
+          <p:cNvSpPr txBox="1"/>
+          <p:nvPr/>
+        </p:nvSpPr>
+        <p:spPr>
+          <a:xfrm>
+            <a:off x="4663440" y="1874520"/>
+            <a:ext cx="2148840" cy="1234440"/>
+          </a:xfrm>
+          <a:prstGeom prst="rect">
+            <a:avLst/>
+          </a:prstGeom>
+          <a:noFill/>
+          <a:ln/>
+        </p:spPr>
+        <p:txBody>
+          <a:bodyPr wrap="square" lIns="0" tIns="0" rIns="0" bIns="0" rtlCol="0" anchor="t"/>
+          <a:lstStyle/>
+          <a:p>
+            <a:pPr indent="0" marL="0">
+              <a:spcAft>
+                <a:spcPts val="400"/>
+              </a:spcAft>
+              <a:buNone/>
+            </a:pPr>
+            <a:r>
+              <a:rPr lang="en-US" sz="1500" b="1" dirty="0">
+                <a:solidFill>
+                  <a:schemeClr val="accent1"/>
+                </a:solidFill>
+              </a:rPr>
+              <a:t>Dotazník bariér → cílený krok</a:t>
+            </a:r>
+            <a:endParaRPr lang="en-US" sz="1500" dirty="0"/>
+          </a:p>
+          <a:p>
+            <a:pPr indent="0" marL="0">
+              <a:buNone/>
+            </a:pPr>
+            <a:r>
+              <a:rPr lang="en-US" sz="1300" dirty="0">
                 <a:solidFill>
                   <a:schemeClr val="tx1"/>
                 </a:solidFill>
               </a:rPr>
-              <a:t>příspěvek jednoho znaku k logitu</a:t>
-            </a:r>
-            <a:r>
-              <a:rPr lang="en-US" sz="1200" dirty="0">
+              <a:t>„Co vám brání?“ → navigace telefonem, večerní termín, doprava, vysvětlení „bez žádanky“</a:t>
+            </a:r>
+            <a:endParaRPr lang="en-US" sz="1500" dirty="0"/>
+          </a:p>
+        </p:txBody>
+      </p:sp>
+      <p:sp>
+        <p:nvSpPr>
+          <p:cNvPr id="12" name="aplikace_3"/>
+          <p:cNvSpPr/>
+          <p:nvPr/>
+        </p:nvSpPr>
+        <p:spPr>
+          <a:xfrm>
+            <a:off x="548640" y="3474720"/>
+            <a:ext cx="3108960" cy="1554480"/>
+          </a:xfrm>
+          <a:prstGeom prst="roundRect">
+            <a:avLst>
+              <a:gd name="adj" fmla="val 4706"/>
+            </a:avLst>
+          </a:prstGeom>
+          <a:solidFill>
+            <a:schemeClr val="bg2"/>
+          </a:solidFill>
+          <a:ln/>
+        </p:spPr>
+      </p:sp>
+      <p:sp>
+        <p:nvSpPr>
+          <p:cNvPr id="13" name="aplikace_3_cislo"/>
+          <p:cNvSpPr/>
+          <p:nvPr/>
+        </p:nvSpPr>
+        <p:spPr>
+          <a:xfrm>
+            <a:off x="731520" y="3657600"/>
+            <a:ext cx="457200" cy="457200"/>
+          </a:xfrm>
+          <a:prstGeom prst="ellipse">
+            <a:avLst/>
+          </a:prstGeom>
+          <a:solidFill>
+            <a:schemeClr val="accent2"/>
+          </a:solidFill>
+          <a:ln/>
+        </p:spPr>
+      </p:sp>
+      <p:sp>
+        <p:nvSpPr>
+          <p:cNvPr id="14" name="aplikace_3_cislo_text"/>
+          <p:cNvSpPr txBox="1"/>
+          <p:nvPr/>
+        </p:nvSpPr>
+        <p:spPr>
+          <a:xfrm>
+            <a:off x="731520" y="3657600"/>
+            <a:ext cx="457200" cy="457200"/>
+          </a:xfrm>
+          <a:prstGeom prst="rect">
+            <a:avLst/>
+          </a:prstGeom>
+          <a:noFill/>
+          <a:ln/>
+        </p:spPr>
+        <p:txBody>
+          <a:bodyPr wrap="square" lIns="0" tIns="0" rIns="0" bIns="0" rtlCol="0" anchor="ctr"/>
+          <a:lstStyle/>
+          <a:p>
+            <a:pPr algn="ctr" indent="0" marL="0">
+              <a:buNone/>
+            </a:pPr>
+            <a:r>
+              <a:rPr lang="en-US" sz="1600" b="1" dirty="0">
+                <a:solidFill>
+                  <a:schemeClr val="bg1"/>
+                </a:solidFill>
+                <a:latin typeface="Cambria" pitchFamily="34" charset="0"/>
+                <a:ea typeface="Cambria" pitchFamily="34" charset="-122"/>
+                <a:cs typeface="Cambria" pitchFamily="34" charset="-120"/>
+              </a:rPr>
+              <a:t>3</a:t>
+            </a:r>
+            <a:endParaRPr lang="en-US" sz="1600" dirty="0"/>
+          </a:p>
+        </p:txBody>
+      </p:sp>
+      <p:sp>
+        <p:nvSpPr>
+          <p:cNvPr id="15" name="aplikace_3_text"/>
+          <p:cNvSpPr txBox="1"/>
+          <p:nvPr/>
+        </p:nvSpPr>
+        <p:spPr>
+          <a:xfrm>
+            <a:off x="1325880" y="3657600"/>
+            <a:ext cx="2148840" cy="1234440"/>
+          </a:xfrm>
+          <a:prstGeom prst="rect">
+            <a:avLst/>
+          </a:prstGeom>
+          <a:noFill/>
+          <a:ln/>
+        </p:spPr>
+        <p:txBody>
+          <a:bodyPr wrap="square" lIns="0" tIns="0" rIns="0" bIns="0" rtlCol="0" anchor="t"/>
+          <a:lstStyle/>
+          <a:p>
+            <a:pPr indent="0" marL="0">
+              <a:spcAft>
+                <a:spcPts val="400"/>
+              </a:spcAft>
+              <a:buNone/>
+            </a:pPr>
+            <a:r>
+              <a:rPr lang="en-US" sz="1500" b="1" dirty="0">
+                <a:solidFill>
+                  <a:schemeClr val="accent1"/>
+                </a:solidFill>
+              </a:rPr>
+              <a:t>Přehled prevence</a:t>
+            </a:r>
+            <a:endParaRPr lang="en-US" sz="1500" dirty="0"/>
+          </a:p>
+          <a:p>
+            <a:pPr indent="0" marL="0">
+              <a:buNone/>
+            </a:pPr>
+            <a:r>
+              <a:rPr lang="en-US" sz="1300" dirty="0">
                 <a:solidFill>
                   <a:schemeClr val="tx1"/>
                 </a:solidFill>
               </a:rPr>
-              <a:t>. Predikce klienta je jejich součet, takže je </a:t>
-            </a:r>
-            <a:r>
-              <a:rPr lang="en-US" sz="1200" b="1" dirty="0">
+              <a:t>vše, co klienta čeká: screeningy, preventivní prohlídky, očkování na jednom místě</a:t>
+            </a:r>
+            <a:endParaRPr lang="en-US" sz="1500" dirty="0"/>
+          </a:p>
+        </p:txBody>
+      </p:sp>
+      <p:sp>
+        <p:nvSpPr>
+          <p:cNvPr id="16" name="aplikace_4"/>
+          <p:cNvSpPr/>
+          <p:nvPr/>
+        </p:nvSpPr>
+        <p:spPr>
+          <a:xfrm>
+            <a:off x="3886200" y="3474720"/>
+            <a:ext cx="3108960" cy="1554480"/>
+          </a:xfrm>
+          <a:prstGeom prst="roundRect">
+            <a:avLst>
+              <a:gd name="adj" fmla="val 4706"/>
+            </a:avLst>
+          </a:prstGeom>
+          <a:solidFill>
+            <a:schemeClr val="bg2"/>
+          </a:solidFill>
+          <a:ln/>
+        </p:spPr>
+      </p:sp>
+      <p:sp>
+        <p:nvSpPr>
+          <p:cNvPr id="17" name="aplikace_4_cislo"/>
+          <p:cNvSpPr/>
+          <p:nvPr/>
+        </p:nvSpPr>
+        <p:spPr>
+          <a:xfrm>
+            <a:off x="4069080" y="3657600"/>
+            <a:ext cx="457200" cy="457200"/>
+          </a:xfrm>
+          <a:prstGeom prst="ellipse">
+            <a:avLst/>
+          </a:prstGeom>
+          <a:solidFill>
+            <a:schemeClr val="accent2"/>
+          </a:solidFill>
+          <a:ln/>
+        </p:spPr>
+      </p:sp>
+      <p:sp>
+        <p:nvSpPr>
+          <p:cNvPr id="18" name="aplikace_4_cislo_text"/>
+          <p:cNvSpPr txBox="1"/>
+          <p:nvPr/>
+        </p:nvSpPr>
+        <p:spPr>
+          <a:xfrm>
+            <a:off x="4069080" y="3657600"/>
+            <a:ext cx="457200" cy="457200"/>
+          </a:xfrm>
+          <a:prstGeom prst="rect">
+            <a:avLst/>
+          </a:prstGeom>
+          <a:noFill/>
+          <a:ln/>
+        </p:spPr>
+        <p:txBody>
+          <a:bodyPr wrap="square" lIns="0" tIns="0" rIns="0" bIns="0" rtlCol="0" anchor="ctr"/>
+          <a:lstStyle/>
+          <a:p>
+            <a:pPr algn="ctr" indent="0" marL="0">
+              <a:buNone/>
+            </a:pPr>
+            <a:r>
+              <a:rPr lang="en-US" sz="1600" b="1" dirty="0">
+                <a:solidFill>
+                  <a:schemeClr val="bg1"/>
+                </a:solidFill>
+                <a:latin typeface="Cambria" pitchFamily="34" charset="0"/>
+                <a:ea typeface="Cambria" pitchFamily="34" charset="-122"/>
+                <a:cs typeface="Cambria" pitchFamily="34" charset="-120"/>
+              </a:rPr>
+              <a:t>4</a:t>
+            </a:r>
+            <a:endParaRPr lang="en-US" sz="1600" dirty="0"/>
+          </a:p>
+        </p:txBody>
+      </p:sp>
+      <p:sp>
+        <p:nvSpPr>
+          <p:cNvPr id="19" name="aplikace_4_text"/>
+          <p:cNvSpPr txBox="1"/>
+          <p:nvPr/>
+        </p:nvSpPr>
+        <p:spPr>
+          <a:xfrm>
+            <a:off x="4663440" y="3657600"/>
+            <a:ext cx="2148840" cy="1234440"/>
+          </a:xfrm>
+          <a:prstGeom prst="rect">
+            <a:avLst/>
+          </a:prstGeom>
+          <a:noFill/>
+          <a:ln/>
+        </p:spPr>
+        <p:txBody>
+          <a:bodyPr wrap="square" lIns="0" tIns="0" rIns="0" bIns="0" rtlCol="0" anchor="t"/>
+          <a:lstStyle/>
+          <a:p>
+            <a:pPr indent="0" marL="0">
+              <a:spcAft>
+                <a:spcPts val="400"/>
+              </a:spcAft>
+              <a:buNone/>
+            </a:pPr>
+            <a:r>
+              <a:rPr lang="en-US" sz="1500" b="1" dirty="0">
+                <a:solidFill>
+                  <a:schemeClr val="accent1"/>
+                </a:solidFill>
+              </a:rPr>
+              <a:t>Připomínky a obsah</a:t>
+            </a:r>
+            <a:endParaRPr lang="en-US" sz="1500" dirty="0"/>
+          </a:p>
+          <a:p>
+            <a:pPr indent="0" marL="0">
+              <a:buNone/>
+            </a:pPr>
+            <a:r>
+              <a:rPr lang="en-US" sz="1300" dirty="0">
                 <a:solidFill>
                   <a:schemeClr val="tx1"/>
                 </a:solidFill>
               </a:rPr>
-              <a:t>přesně</a:t>
-            </a:r>
-            <a:r>
-              <a:rPr lang="en-US" sz="1200" dirty="0">
-                <a:solidFill>
-                  <a:schemeClr val="tx1"/>
-                </a:solidFill>
-              </a:rPr>
-              <a:t> vidět, proč vyšla. Křivky jsou ilustrativní.</a:t>
+              <a:t>stejné zprávy jako SMS a dopis, zdarma, s rezervací na jedno klepnutí a variantami k testování</a:t>
             </a:r>
             <a:endParaRPr lang="en-US" sz="1500" dirty="0"/>
           </a:p>
@@ -4603,14 +4948,36 @@
       </p:sp>
       <p:sp>
         <p:nvSpPr>
-          <p:cNvPr id="10" name="proc_ebm"/>
+          <p:cNvPr id="20" name="zpet"/>
+          <p:cNvSpPr/>
+          <p:nvPr/>
+        </p:nvSpPr>
+        <p:spPr>
+          <a:xfrm>
+            <a:off x="7315200" y="1234440"/>
+            <a:ext cx="4327855" cy="3794760"/>
+          </a:xfrm>
+          <a:prstGeom prst="roundRect">
+            <a:avLst>
+              <a:gd name="adj" fmla="val 1928"/>
+            </a:avLst>
+          </a:prstGeom>
+          <a:solidFill>
+            <a:schemeClr val="accent1"/>
+          </a:solidFill>
+          <a:ln/>
+        </p:spPr>
+      </p:sp>
+      <p:sp>
+        <p:nvSpPr>
+          <p:cNvPr id="21" name="zpet_text"/>
           <p:cNvSpPr txBox="1"/>
           <p:nvPr/>
         </p:nvSpPr>
         <p:spPr>
           <a:xfrm>
-            <a:off x="6629400" y="2103120"/>
-            <a:ext cx="5013655" cy="3931920"/>
+            <a:off x="7543800" y="1417320"/>
+            <a:ext cx="3870655" cy="3474720"/>
           </a:xfrm>
           <a:prstGeom prst="rect">
             <a:avLst/>
@@ -4622,194 +4989,191 @@
           <a:bodyPr wrap="square" lIns="0" tIns="0" rIns="0" bIns="0" rtlCol="0" anchor="t"/>
           <a:lstStyle/>
           <a:p>
-            <a:pPr marL="203200" indent="-203200">
+            <a:pPr indent="0" marL="0">
               <a:spcAft>
                 <a:spcPts val="800"/>
               </a:spcAft>
-              <a:buSzPct val="100000"/>
-              <a:buChar char="•"/>
-            </a:pPr>
-            <a:r>
-              <a:rPr lang="en-US" sz="1400" b="1" dirty="0">
-                <a:solidFill>
-                  <a:schemeClr val="tx1"/>
-                </a:solidFill>
-              </a:rPr>
-              <a:t>Skleněná skříňka:</a:t>
-            </a:r>
-            <a:r>
-              <a:rPr lang="en-US" sz="1400" dirty="0">
-                <a:solidFill>
-                  <a:schemeClr val="tx1"/>
-                </a:solidFill>
-              </a:rPr>
-              <a:t> model je přímo čitelný, rozklad predikce je přesný (ne dodatečná aproximace jako SHAP nad černou skříňkou).</a:t>
-            </a:r>
-            <a:endParaRPr lang="en-US" sz="1400" dirty="0"/>
-          </a:p>
-          <a:p>
-            <a:pPr marL="203200" indent="-203200">
+              <a:buNone/>
+            </a:pPr>
+            <a:r>
+              <a:rPr lang="en-US" sz="1600" b="1" dirty="0">
+                <a:solidFill>
+                  <a:schemeClr val="bg1"/>
+                </a:solidFill>
+              </a:rPr>
+              <a:t>Co se vrací do VZP</a:t>
+            </a:r>
+            <a:endParaRPr lang="en-US" sz="1600" dirty="0"/>
+          </a:p>
+          <a:p>
+            <a:pPr marL="177800" indent="-177800">
               <a:spcAft>
-                <a:spcPts val="800"/>
+                <a:spcPts val="1400"/>
               </a:spcAft>
               <a:buSzPct val="100000"/>
               <a:buChar char="•"/>
             </a:pPr>
             <a:r>
-              <a:rPr lang="en-US" sz="1400" b="1" dirty="0">
-                <a:solidFill>
-                  <a:schemeClr val="tx1"/>
-                </a:solidFill>
-              </a:rPr>
-              <a:t>Přesnost</a:t>
-            </a:r>
-            <a:r>
-              <a:rPr lang="en-US" sz="1400" dirty="0">
-                <a:solidFill>
-                  <a:schemeClr val="tx1"/>
-                </a:solidFill>
-              </a:rPr>
-              <a:t> na tabulkových datech blízko gradient boostingu, </a:t>
-            </a:r>
-            <a:r>
-              <a:rPr lang="en-US" sz="1400" b="1" dirty="0">
-                <a:solidFill>
-                  <a:schemeClr val="tx1"/>
-                </a:solidFill>
-              </a:rPr>
-              <a:t>dobře kalibrované pravděpodobnosti</a:t>
-            </a:r>
-            <a:r>
-              <a:rPr lang="en-US" sz="1400" dirty="0">
-                <a:solidFill>
-                  <a:schemeClr val="tx1"/>
-                </a:solidFill>
-              </a:rPr>
-              <a:t> pro optimalizaci a ekonomiku.</a:t>
-            </a:r>
-            <a:endParaRPr lang="en-US" sz="1400" dirty="0"/>
-          </a:p>
-          <a:p>
-            <a:pPr marL="203200" indent="-203200">
+              <a:rPr lang="en-US" sz="1500" b="1" dirty="0">
+                <a:solidFill>
+                  <a:schemeClr val="bg1"/>
+                </a:solidFill>
+              </a:rPr>
+              <a:t>Důvody, proč klient nepřišel:</a:t>
+            </a:r>
+            <a:r>
+              <a:rPr lang="en-US" sz="1500" dirty="0">
+                <a:solidFill>
+                  <a:schemeClr val="bg1"/>
+                </a:solidFill>
+              </a:rPr>
+              <a:t> znaky pro segmentaci a model upliftu</a:t>
+            </a:r>
+            <a:endParaRPr lang="en-US" sz="1600" dirty="0"/>
+          </a:p>
+          <a:p>
+            <a:pPr marL="177800" indent="-177800">
               <a:spcAft>
-                <a:spcPts val="800"/>
+                <a:spcPts val="1400"/>
               </a:spcAft>
               <a:buSzPct val="100000"/>
               <a:buChar char="•"/>
             </a:pPr>
             <a:r>
-              <a:rPr lang="en-US" sz="1400" b="1" dirty="0">
-                <a:solidFill>
-                  <a:schemeClr val="tx1"/>
-                </a:solidFill>
-              </a:rPr>
-              <a:t>Kontrola:</a:t>
-            </a:r>
-            <a:r>
-              <a:rPr lang="en-US" sz="1400" dirty="0">
-                <a:solidFill>
-                  <a:schemeClr val="tx1"/>
-                </a:solidFill>
-              </a:rPr>
-              <a:t> monotónní omezení, úprava křivek s lékaři, kontrola férovosti podle regionů a skupin.</a:t>
-            </a:r>
-            <a:endParaRPr lang="en-US" sz="1400" dirty="0"/>
-          </a:p>
-          <a:p>
-            <a:pPr marL="203200" indent="-203200">
+              <a:rPr lang="en-US" sz="1500" b="1" dirty="0">
+                <a:solidFill>
+                  <a:schemeClr val="bg1"/>
+                </a:solidFill>
+              </a:rPr>
+              <a:t>Zkušenost po vyšetření:</a:t>
+            </a:r>
+            <a:r>
+              <a:rPr lang="en-US" sz="1500" dirty="0">
+                <a:solidFill>
+                  <a:schemeClr val="bg1"/>
+                </a:solidFill>
+              </a:rPr>
+              <a:t> kvalita poskytovatelů, návyk</a:t>
+            </a:r>
+            <a:endParaRPr lang="en-US" sz="1600" dirty="0"/>
+          </a:p>
+          <a:p>
+            <a:pPr marL="177800" indent="-177800">
               <a:spcAft>
-                <a:spcPts val="800"/>
+                <a:spcPts val="1400"/>
               </a:spcAft>
               <a:buSzPct val="100000"/>
               <a:buChar char="•"/>
             </a:pPr>
             <a:r>
-              <a:rPr lang="en-US" sz="1400" b="1" dirty="0">
-                <a:solidFill>
-                  <a:schemeClr val="tx1"/>
-                </a:solidFill>
-              </a:rPr>
-              <a:t>Regulace:</a:t>
-            </a:r>
-            <a:r>
-              <a:rPr lang="en-US" sz="1400" dirty="0">
-                <a:solidFill>
-                  <a:schemeClr val="tx1"/>
-                </a:solidFill>
-              </a:rPr>
-              <a:t> vysvětlení pro klienta, lékaře i regulátora (GDPR čl. 22, AI Act).</a:t>
-            </a:r>
-            <a:endParaRPr lang="en-US" sz="1400" dirty="0"/>
-          </a:p>
-          <a:p>
-            <a:pPr marL="203200" indent="-203200">
+              <a:rPr lang="en-US" sz="1500" b="1" dirty="0">
+                <a:solidFill>
+                  <a:schemeClr val="bg1"/>
+                </a:solidFill>
+              </a:rPr>
+              <a:t>Dosažitelnost kanálů:</a:t>
+            </a:r>
+            <a:r>
+              <a:rPr lang="en-US" sz="1500" dirty="0">
+                <a:solidFill>
+                  <a:schemeClr val="bg1"/>
+                </a:solidFill>
+              </a:rPr>
+              <a:t> komu co funguje, omezení pro optimalizaci</a:t>
+            </a:r>
+            <a:endParaRPr lang="en-US" sz="1600" dirty="0"/>
+          </a:p>
+          <a:p>
+            <a:pPr marL="177800" indent="-177800">
               <a:spcAft>
-                <a:spcPts val="800"/>
+                <a:spcPts val="1400"/>
               </a:spcAft>
               <a:buSzPct val="100000"/>
               <a:buChar char="•"/>
             </a:pPr>
             <a:r>
-              <a:rPr lang="en-US" sz="1400" b="1" dirty="0">
+              <a:rPr lang="en-US" sz="1500" b="1" dirty="0">
+                <a:solidFill>
+                  <a:schemeClr val="bg1"/>
+                </a:solidFill>
+              </a:rPr>
+              <a:t>Platforma pro pokusy:</a:t>
+            </a:r>
+            <a:r>
+              <a:rPr lang="en-US" sz="1500" dirty="0">
+                <a:solidFill>
+                  <a:schemeClr val="bg1"/>
+                </a:solidFill>
+              </a:rPr>
+              <a:t> levná randomizace, zaznamenané přiřazení, signály za dny</a:t>
+            </a:r>
+            <a:endParaRPr lang="en-US" sz="1600" dirty="0"/>
+          </a:p>
+        </p:txBody>
+      </p:sp>
+      <p:sp>
+        <p:nvSpPr>
+          <p:cNvPr id="22" name="pozor"/>
+          <p:cNvSpPr/>
+          <p:nvPr/>
+        </p:nvSpPr>
+        <p:spPr>
+          <a:xfrm>
+            <a:off x="548640" y="5257800"/>
+            <a:ext cx="11094415" cy="1097280"/>
+          </a:xfrm>
+          <a:prstGeom prst="roundRect">
+            <a:avLst>
+              <a:gd name="adj" fmla="val 6667"/>
+            </a:avLst>
+          </a:prstGeom>
+          <a:solidFill>
+            <a:schemeClr val="bg2"/>
+          </a:solidFill>
+          <a:ln/>
+        </p:spPr>
+      </p:sp>
+      <p:sp>
+        <p:nvSpPr>
+          <p:cNvPr id="23" name="pozor_text"/>
+          <p:cNvSpPr txBox="1"/>
+          <p:nvPr/>
+        </p:nvSpPr>
+        <p:spPr>
+          <a:xfrm>
+            <a:off x="777240" y="5394960"/>
+            <a:ext cx="10637215" cy="822960"/>
+          </a:xfrm>
+          <a:prstGeom prst="rect">
+            <a:avLst/>
+          </a:prstGeom>
+          <a:noFill/>
+          <a:ln/>
+        </p:spPr>
+        <p:txBody>
+          <a:bodyPr wrap="square" lIns="0" tIns="0" rIns="0" bIns="0" rtlCol="0" anchor="ctr"/>
+          <a:lstStyle/>
+          <a:p>
+            <a:pPr indent="0" marL="0">
+              <a:buNone/>
+            </a:pPr>
+            <a:r>
+              <a:rPr lang="en-US" sz="1350" b="1" dirty="0">
+                <a:solidFill>
+                  <a:schemeClr val="accent1"/>
+                </a:solidFill>
+              </a:rPr>
+              <a:t>Pozor: </a:t>
+            </a:r>
+            <a:r>
+              <a:rPr lang="en-US" sz="1300" dirty="0">
                 <a:solidFill>
                   <a:schemeClr val="tx1"/>
                 </a:solidFill>
               </a:rPr>
-              <a:t>Prior pro uplift:</a:t>
-            </a:r>
-            <a:r>
-              <a:rPr lang="en-US" sz="1400" dirty="0">
-                <a:solidFill>
-                  <a:schemeClr val="tx1"/>
-                </a:solidFill>
-              </a:rPr>
-              <a:t> logit EBM je výchozí bod modelu účinku intervencí (další snímek).</a:t>
-            </a:r>
-            <a:endParaRPr lang="en-US" sz="1400" dirty="0"/>
-          </a:p>
-        </p:txBody>
-      </p:sp>
-      <p:sp>
-        <p:nvSpPr>
-          <p:cNvPr id="11" name="alternativy"/>
-          <p:cNvSpPr txBox="1"/>
-          <p:nvPr/>
-        </p:nvSpPr>
-        <p:spPr>
-          <a:xfrm>
-            <a:off x="6629400" y="5623560"/>
-            <a:ext cx="5013655" cy="685800"/>
-          </a:xfrm>
-          <a:prstGeom prst="rect">
-            <a:avLst/>
-          </a:prstGeom>
-          <a:noFill/>
-          <a:ln/>
-        </p:spPr>
-        <p:txBody>
-          <a:bodyPr wrap="square" lIns="0" tIns="0" rIns="0" bIns="0" rtlCol="0" anchor="t"/>
-          <a:lstStyle/>
-          <a:p>
-            <a:pPr indent="0" marL="0">
-              <a:buNone/>
-            </a:pPr>
-            <a:r>
-              <a:rPr lang="en-US" sz="1100" b="1" dirty="0">
-                <a:solidFill>
-                  <a:schemeClr val="accent4"/>
-                </a:solidFill>
-              </a:rPr>
-              <a:t>Zvážené alternativy:</a:t>
-            </a:r>
-            <a:r>
-              <a:rPr lang="en-US" sz="1100" dirty="0">
-                <a:solidFill>
-                  <a:schemeClr val="accent4"/>
-                </a:solidFill>
-              </a:rPr>
-              <a:t> logit se splajny (málo pružný), skórkarta (méně přesná), GBM + SHAP (jen dodatečné vysvětlení; zůstává jako měřítko ceny vysvětlitelnosti).</a:t>
-            </a:r>
-            <a:endParaRPr lang="en-US" sz="1100" dirty="0"/>
+              <a:t>uživatelé aplikace jsou výběr: chodí častěji a nejtěžší segmenty zastihne aplikace nejméně, takže výsledky platí jen pro ně a dopis, SMS ani telefon nenahradí. Krátké a řídké dotazníky (únava, zkreslení odpovědí), souhlas s využitím odpovědí (GDPR). Výsledek měřit vykázaným výkonem, ne kliknutím.</a:t>
+            </a:r>
+            <a:endParaRPr lang="en-US" sz="1350" dirty="0"/>
           </a:p>
         </p:txBody>
       </p:sp>
@@ -4915,7 +5279,7 @@
                   <a:schemeClr val="accent1"/>
                 </a:solidFill>
               </a:rPr>
-              <a:t>Model upliftu: bayesovský, s modelem účasti jako priorem</a:t>
+              <a:t>Model pravděpodobnosti účasti: vysvětlitelný (EBM)</a:t>
             </a:r>
             <a:endParaRPr lang="en-US" sz="3000" dirty="0"/>
           </a:p>
@@ -4923,18 +5287,228 @@
       </p:sp>
       <p:sp>
         <p:nvSpPr>
-          <p:cNvPr id="3" name="prior_ebm"/>
+          <p:cNvPr id="3" name="vzorec"/>
           <p:cNvSpPr/>
           <p:nvPr/>
         </p:nvSpPr>
         <p:spPr>
           <a:xfrm>
             <a:off x="548640" y="1234440"/>
-            <a:ext cx="2743200" cy="1188720"/>
+            <a:ext cx="11094415" cy="640080"/>
           </a:xfrm>
           <a:prstGeom prst="roundRect">
             <a:avLst>
-              <a:gd name="adj" fmla="val 6154"/>
+              <a:gd name="adj" fmla="val 11429"/>
+            </a:avLst>
+          </a:prstGeom>
+          <a:solidFill>
+            <a:schemeClr val="accent1"/>
+          </a:solidFill>
+          <a:ln/>
+        </p:spPr>
+      </p:sp>
+      <p:sp>
+        <p:nvSpPr>
+          <p:cNvPr id="4" name="vzorec_text"/>
+          <p:cNvSpPr txBox="1"/>
+          <p:nvPr/>
+        </p:nvSpPr>
+        <p:spPr>
+          <a:xfrm>
+            <a:off x="777240" y="1325880"/>
+            <a:ext cx="10637215" cy="457200"/>
+          </a:xfrm>
+          <a:prstGeom prst="rect">
+            <a:avLst/>
+          </a:prstGeom>
+          <a:noFill/>
+          <a:ln/>
+        </p:spPr>
+        <p:txBody>
+          <a:bodyPr wrap="square" lIns="0" tIns="0" rIns="0" bIns="0" rtlCol="0" anchor="ctr"/>
+          <a:lstStyle/>
+          <a:p>
+            <a:pPr indent="0" marL="0">
+              <a:buNone/>
+            </a:pPr>
+            <a:r>
+              <a:rPr lang="en-US" sz="1800" dirty="0">
+                <a:solidFill>
+                  <a:schemeClr val="bg1"/>
+                </a:solidFill>
+              </a:rPr>
+              <a:t>logit p(x) = β</a:t>
+            </a:r>
+            <a:r>
+              <a:rPr lang="en-US" sz="1800" baseline="-40000" dirty="0">
+                <a:solidFill>
+                  <a:schemeClr val="bg1"/>
+                </a:solidFill>
+              </a:rPr>
+              <a:t>0</a:t>
+            </a:r>
+            <a:r>
+              <a:rPr lang="en-US" sz="1800" dirty="0">
+                <a:solidFill>
+                  <a:schemeClr val="bg1"/>
+                </a:solidFill>
+              </a:rPr>
+              <a:t> + Σ f</a:t>
+            </a:r>
+            <a:r>
+              <a:rPr lang="en-US" sz="1800" baseline="-40000" dirty="0">
+                <a:solidFill>
+                  <a:schemeClr val="bg1"/>
+                </a:solidFill>
+              </a:rPr>
+              <a:t>j</a:t>
+            </a:r>
+            <a:r>
+              <a:rPr lang="en-US" sz="1800" dirty="0">
+                <a:solidFill>
+                  <a:schemeClr val="bg1"/>
+                </a:solidFill>
+              </a:rPr>
+              <a:t>(x</a:t>
+            </a:r>
+            <a:r>
+              <a:rPr lang="en-US" sz="1800" baseline="-40000" dirty="0">
+                <a:solidFill>
+                  <a:schemeClr val="bg1"/>
+                </a:solidFill>
+              </a:rPr>
+              <a:t>j</a:t>
+            </a:r>
+            <a:r>
+              <a:rPr lang="en-US" sz="1800" dirty="0">
+                <a:solidFill>
+                  <a:schemeClr val="bg1"/>
+                </a:solidFill>
+              </a:rPr>
+              <a:t>) + Σ f</a:t>
+            </a:r>
+            <a:r>
+              <a:rPr lang="en-US" sz="1800" baseline="-40000" dirty="0">
+                <a:solidFill>
+                  <a:schemeClr val="bg1"/>
+                </a:solidFill>
+              </a:rPr>
+              <a:t>ij</a:t>
+            </a:r>
+            <a:r>
+              <a:rPr lang="en-US" sz="1800" dirty="0">
+                <a:solidFill>
+                  <a:schemeClr val="bg1"/>
+                </a:solidFill>
+              </a:rPr>
+              <a:t>(x</a:t>
+            </a:r>
+            <a:r>
+              <a:rPr lang="en-US" sz="1800" baseline="-40000" dirty="0">
+                <a:solidFill>
+                  <a:schemeClr val="bg1"/>
+                </a:solidFill>
+              </a:rPr>
+              <a:t>i</a:t>
+            </a:r>
+            <a:r>
+              <a:rPr lang="en-US" sz="1800" dirty="0">
+                <a:solidFill>
+                  <a:schemeClr val="bg1"/>
+                </a:solidFill>
+              </a:rPr>
+              <a:t>, x</a:t>
+            </a:r>
+            <a:r>
+              <a:rPr lang="en-US" sz="1800" baseline="-40000" dirty="0">
+                <a:solidFill>
+                  <a:schemeClr val="bg1"/>
+                </a:solidFill>
+              </a:rPr>
+              <a:t>j</a:t>
+            </a:r>
+            <a:r>
+              <a:rPr lang="en-US" sz="1800" dirty="0">
+                <a:solidFill>
+                  <a:schemeClr val="bg1"/>
+                </a:solidFill>
+              </a:rPr>
+              <a:t>)</a:t>
+            </a:r>
+            <a:r>
+              <a:rPr lang="en-US" sz="1300" dirty="0">
+                <a:solidFill>
+                  <a:schemeClr val="accent3"/>
+                </a:solidFill>
+              </a:rPr>
+              <a:t>     Explainable Boosting Machine: zobecněný aditivní model s vybranými interakcemi, učený boostingem</a:t>
+            </a:r>
+            <a:endParaRPr lang="en-US" sz="1800" dirty="0"/>
+          </a:p>
+        </p:txBody>
+      </p:sp>
+      <p:graphicFrame>
+        <p:nvGraphicFramePr>
+          <p:cNvPr id="5" name="tvarova_funkce_1" descr=""/>
+          <p:cNvGraphicFramePr/>
+          <p:nvPr/>
+        </p:nvGraphicFramePr>
+        <p:xfrm>
+          <a:off x="548640" y="2103120"/>
+          <a:ext cx="2788920" cy="1965960"/>
+        </p:xfrm>
+        <a:graphic xmlns:a="http://schemas.openxmlformats.org/drawingml/2006/main">
+          <a:graphicData uri="http://schemas.openxmlformats.org/drawingml/2006/chart">
+            <c:chart xmlns:c="http://schemas.openxmlformats.org/drawingml/2006/chart" r:id="rId1"/>
+          </a:graphicData>
+        </a:graphic>
+      </p:graphicFrame>
+      <p:graphicFrame>
+        <p:nvGraphicFramePr>
+          <p:cNvPr id="6" name="tvarova_funkce_2" descr=""/>
+          <p:cNvGraphicFramePr/>
+          <p:nvPr/>
+        </p:nvGraphicFramePr>
+        <p:xfrm>
+          <a:off x="3520440" y="2103120"/>
+          <a:ext cx="2788920" cy="1965960"/>
+        </p:xfrm>
+        <a:graphic xmlns:a="http://schemas.openxmlformats.org/drawingml/2006/main">
+          <a:graphicData uri="http://schemas.openxmlformats.org/drawingml/2006/chart">
+            <c:chart xmlns:c="http://schemas.openxmlformats.org/drawingml/2006/chart" r:id="rId2"/>
+          </a:graphicData>
+        </a:graphic>
+      </p:graphicFrame>
+      <p:graphicFrame>
+        <p:nvGraphicFramePr>
+          <p:cNvPr id="7" name="tvarova_funkce_3" descr=""/>
+          <p:cNvGraphicFramePr/>
+          <p:nvPr/>
+        </p:nvGraphicFramePr>
+        <p:xfrm>
+          <a:off x="548640" y="4251960"/>
+          <a:ext cx="2788920" cy="1965960"/>
+        </p:xfrm>
+        <a:graphic xmlns:a="http://schemas.openxmlformats.org/drawingml/2006/main">
+          <a:graphicData uri="http://schemas.openxmlformats.org/drawingml/2006/chart">
+            <c:chart xmlns:c="http://schemas.openxmlformats.org/drawingml/2006/chart" r:id="rId3"/>
+          </a:graphicData>
+        </a:graphic>
+      </p:graphicFrame>
+      <p:sp>
+        <p:nvSpPr>
+          <p:cNvPr id="8" name="jak_cist"/>
+          <p:cNvSpPr/>
+          <p:nvPr/>
+        </p:nvSpPr>
+        <p:spPr>
+          <a:xfrm>
+            <a:off x="3520440" y="4251960"/>
+            <a:ext cx="2788920" cy="1965960"/>
+          </a:xfrm>
+          <a:prstGeom prst="roundRect">
+            <a:avLst>
+              <a:gd name="adj" fmla="val 3721"/>
             </a:avLst>
           </a:prstGeom>
           <a:solidFill>
@@ -4945,14 +5519,14 @@
       </p:sp>
       <p:sp>
         <p:nvSpPr>
-          <p:cNvPr id="4" name="prior_ebm_text"/>
+          <p:cNvPr id="9" name="jak_cist_text"/>
           <p:cNvSpPr txBox="1"/>
           <p:nvPr/>
         </p:nvSpPr>
         <p:spPr>
           <a:xfrm>
-            <a:off x="713232" y="1366114"/>
-            <a:ext cx="2414016" cy="925373"/>
+            <a:off x="3685032" y="4383634"/>
+            <a:ext cx="2459736" cy="1702613"/>
           </a:xfrm>
           <a:prstGeom prst="rect">
             <a:avLst/>
@@ -4971,71 +5545,73 @@
               <a:buNone/>
             </a:pPr>
             <a:r>
-              <a:rPr lang="en-US" sz="1550" b="1" dirty="0">
+              <a:rPr lang="en-US" sz="1500" b="1" dirty="0">
                 <a:solidFill>
                   <a:schemeClr val="accent1"/>
                 </a:solidFill>
               </a:rPr>
-              <a:t>Model účasti (EBM)</a:t>
-            </a:r>
-            <a:endParaRPr lang="en-US" sz="1550" dirty="0"/>
+              <a:t>Jak číst</a:t>
+            </a:r>
+            <a:endParaRPr lang="en-US" sz="1500" dirty="0"/>
           </a:p>
           <a:p>
             <a:pPr indent="0" marL="0">
               <a:buNone/>
             </a:pPr>
             <a:r>
-              <a:rPr lang="en-US" sz="1250" dirty="0">
+              <a:rPr lang="en-US" sz="1200" dirty="0">
                 <a:solidFill>
                   <a:schemeClr val="tx1"/>
                 </a:solidFill>
               </a:rPr>
-              <a:t>f(x): výchozí logit klienta, </a:t>
-            </a:r>
-            <a:r>
-              <a:rPr lang="en-US" sz="1250" b="1" dirty="0">
+              <a:t>Každá křivka je </a:t>
+            </a:r>
+            <a:r>
+              <a:rPr lang="en-US" sz="1200" b="1" dirty="0">
                 <a:solidFill>
                   <a:schemeClr val="tx1"/>
                 </a:solidFill>
               </a:rPr>
-              <a:t>prior pro uplift</a:t>
-            </a:r>
-            <a:endParaRPr lang="en-US" sz="1550" dirty="0"/>
-          </a:p>
-        </p:txBody>
-      </p:sp>
-      <p:sp>
-        <p:nvSpPr>
-          <p:cNvPr id="5" name="prior_literatura"/>
-          <p:cNvSpPr/>
-          <p:nvPr/>
-        </p:nvSpPr>
-        <p:spPr>
-          <a:xfrm>
-            <a:off x="548640" y="2651760"/>
-            <a:ext cx="2743200" cy="1188720"/>
-          </a:xfrm>
-          <a:prstGeom prst="roundRect">
-            <a:avLst>
-              <a:gd name="adj" fmla="val 6154"/>
-            </a:avLst>
-          </a:prstGeom>
-          <a:solidFill>
-            <a:schemeClr val="bg2"/>
-          </a:solidFill>
-          <a:ln/>
-        </p:spPr>
-      </p:sp>
-      <p:sp>
-        <p:nvSpPr>
-          <p:cNvPr id="6" name="prior_literatura_text"/>
+              <a:t>příspěvek jednoho znaku k logitu</a:t>
+            </a:r>
+            <a:r>
+              <a:rPr lang="en-US" sz="1200" dirty="0">
+                <a:solidFill>
+                  <a:schemeClr val="tx1"/>
+                </a:solidFill>
+              </a:rPr>
+              <a:t>. Predikce klienta je jejich součet, takže je </a:t>
+            </a:r>
+            <a:r>
+              <a:rPr lang="en-US" sz="1200" b="1" dirty="0">
+                <a:solidFill>
+                  <a:schemeClr val="tx1"/>
+                </a:solidFill>
+              </a:rPr>
+              <a:t>přesně</a:t>
+            </a:r>
+            <a:r>
+              <a:rPr lang="en-US" sz="1200" dirty="0">
+                <a:solidFill>
+                  <a:schemeClr val="tx1"/>
+                </a:solidFill>
+              </a:rPr>
+              <a:t> vidět, proč vyšla. Křivky jsou ilustrativní.</a:t>
+            </a:r>
+            <a:endParaRPr lang="en-US" sz="1500" dirty="0"/>
+          </a:p>
+        </p:txBody>
+      </p:sp>
+      <p:sp>
+        <p:nvSpPr>
+          <p:cNvPr id="10" name="proc_ebm"/>
           <p:cNvSpPr txBox="1"/>
           <p:nvPr/>
         </p:nvSpPr>
         <p:spPr>
           <a:xfrm>
-            <a:off x="713232" y="2783434"/>
-            <a:ext cx="2414016" cy="925373"/>
+            <a:off x="6629400" y="2103120"/>
+            <a:ext cx="5013655" cy="3931920"/>
           </a:xfrm>
           <a:prstGeom prst="rect">
             <a:avLst/>
@@ -5047,895 +5623,194 @@
           <a:bodyPr wrap="square" lIns="0" tIns="0" rIns="0" bIns="0" rtlCol="0" anchor="t"/>
           <a:lstStyle/>
           <a:p>
+            <a:pPr marL="203200" indent="-203200">
+              <a:spcAft>
+                <a:spcPts val="800"/>
+              </a:spcAft>
+              <a:buSzPct val="100000"/>
+              <a:buChar char="•"/>
+            </a:pPr>
+            <a:r>
+              <a:rPr lang="en-US" sz="1400" b="1" dirty="0">
+                <a:solidFill>
+                  <a:schemeClr val="tx1"/>
+                </a:solidFill>
+              </a:rPr>
+              <a:t>Skleněná skříňka:</a:t>
+            </a:r>
+            <a:r>
+              <a:rPr lang="en-US" sz="1400" dirty="0">
+                <a:solidFill>
+                  <a:schemeClr val="tx1"/>
+                </a:solidFill>
+              </a:rPr>
+              <a:t> model je přímo čitelný, rozklad predikce je přesný (ne dodatečná aproximace jako SHAP nad černou skříňkou).</a:t>
+            </a:r>
+            <a:endParaRPr lang="en-US" sz="1400" dirty="0"/>
+          </a:p>
+          <a:p>
+            <a:pPr marL="203200" indent="-203200">
+              <a:spcAft>
+                <a:spcPts val="800"/>
+              </a:spcAft>
+              <a:buSzPct val="100000"/>
+              <a:buChar char="•"/>
+            </a:pPr>
+            <a:r>
+              <a:rPr lang="en-US" sz="1400" b="1" dirty="0">
+                <a:solidFill>
+                  <a:schemeClr val="tx1"/>
+                </a:solidFill>
+              </a:rPr>
+              <a:t>Přesnost</a:t>
+            </a:r>
+            <a:r>
+              <a:rPr lang="en-US" sz="1400" dirty="0">
+                <a:solidFill>
+                  <a:schemeClr val="tx1"/>
+                </a:solidFill>
+              </a:rPr>
+              <a:t> na tabulkových datech blízko gradient boostingu, </a:t>
+            </a:r>
+            <a:r>
+              <a:rPr lang="en-US" sz="1400" b="1" dirty="0">
+                <a:solidFill>
+                  <a:schemeClr val="tx1"/>
+                </a:solidFill>
+              </a:rPr>
+              <a:t>dobře kalibrované pravděpodobnosti</a:t>
+            </a:r>
+            <a:r>
+              <a:rPr lang="en-US" sz="1400" dirty="0">
+                <a:solidFill>
+                  <a:schemeClr val="tx1"/>
+                </a:solidFill>
+              </a:rPr>
+              <a:t> pro optimalizaci a ekonomiku.</a:t>
+            </a:r>
+            <a:endParaRPr lang="en-US" sz="1400" dirty="0"/>
+          </a:p>
+          <a:p>
+            <a:pPr marL="203200" indent="-203200">
+              <a:spcAft>
+                <a:spcPts val="800"/>
+              </a:spcAft>
+              <a:buSzPct val="100000"/>
+              <a:buChar char="•"/>
+            </a:pPr>
+            <a:r>
+              <a:rPr lang="en-US" sz="1400" b="1" dirty="0">
+                <a:solidFill>
+                  <a:schemeClr val="tx1"/>
+                </a:solidFill>
+              </a:rPr>
+              <a:t>Kontrola:</a:t>
+            </a:r>
+            <a:r>
+              <a:rPr lang="en-US" sz="1400" dirty="0">
+                <a:solidFill>
+                  <a:schemeClr val="tx1"/>
+                </a:solidFill>
+              </a:rPr>
+              <a:t> monotónní omezení, úprava křivek s lékaři, kontrola férovosti podle regionů a skupin.</a:t>
+            </a:r>
+            <a:endParaRPr lang="en-US" sz="1400" dirty="0"/>
+          </a:p>
+          <a:p>
+            <a:pPr marL="203200" indent="-203200">
+              <a:spcAft>
+                <a:spcPts val="800"/>
+              </a:spcAft>
+              <a:buSzPct val="100000"/>
+              <a:buChar char="•"/>
+            </a:pPr>
+            <a:r>
+              <a:rPr lang="en-US" sz="1400" b="1" dirty="0">
+                <a:solidFill>
+                  <a:schemeClr val="tx1"/>
+                </a:solidFill>
+              </a:rPr>
+              <a:t>Regulace:</a:t>
+            </a:r>
+            <a:r>
+              <a:rPr lang="en-US" sz="1400" dirty="0">
+                <a:solidFill>
+                  <a:schemeClr val="tx1"/>
+                </a:solidFill>
+              </a:rPr>
+              <a:t> vysvětlení pro klienta, lékaře i regulátora (GDPR čl. 22, AI Act).</a:t>
+            </a:r>
+            <a:endParaRPr lang="en-US" sz="1400" dirty="0"/>
+          </a:p>
+          <a:p>
+            <a:pPr marL="203200" indent="-203200">
+              <a:spcAft>
+                <a:spcPts val="800"/>
+              </a:spcAft>
+              <a:buSzPct val="100000"/>
+              <a:buChar char="•"/>
+            </a:pPr>
+            <a:r>
+              <a:rPr lang="en-US" sz="1400" b="1" dirty="0">
+                <a:solidFill>
+                  <a:schemeClr val="tx1"/>
+                </a:solidFill>
+              </a:rPr>
+              <a:t>Prior pro uplift:</a:t>
+            </a:r>
+            <a:r>
+              <a:rPr lang="en-US" sz="1400" dirty="0">
+                <a:solidFill>
+                  <a:schemeClr val="tx1"/>
+                </a:solidFill>
+              </a:rPr>
+              <a:t> logit EBM je výchozí bod modelu účinku intervencí (další snímek).</a:t>
+            </a:r>
+            <a:endParaRPr lang="en-US" sz="1400" dirty="0"/>
+          </a:p>
+        </p:txBody>
+      </p:sp>
+      <p:sp>
+        <p:nvSpPr>
+          <p:cNvPr id="11" name="alternativy"/>
+          <p:cNvSpPr txBox="1"/>
+          <p:nvPr/>
+        </p:nvSpPr>
+        <p:spPr>
+          <a:xfrm>
+            <a:off x="6629400" y="5623560"/>
+            <a:ext cx="5013655" cy="685800"/>
+          </a:xfrm>
+          <a:prstGeom prst="rect">
+            <a:avLst/>
+          </a:prstGeom>
+          <a:noFill/>
+          <a:ln/>
+        </p:spPr>
+        <p:txBody>
+          <a:bodyPr wrap="square" lIns="0" tIns="0" rIns="0" bIns="0" rtlCol="0" anchor="t"/>
+          <a:lstStyle/>
+          <a:p>
             <a:pPr indent="0" marL="0">
-              <a:spcAft>
-                <a:spcPts val="400"/>
-              </a:spcAft>
-              <a:buNone/>
-            </a:pPr>
-            <a:r>
-              <a:rPr lang="en-US" sz="1550" b="1" dirty="0">
-                <a:solidFill>
-                  <a:schemeClr val="accent1"/>
-                </a:solidFill>
-              </a:rPr>
-              <a:t>Literatura</a:t>
-            </a:r>
-            <a:endParaRPr lang="en-US" sz="1550" dirty="0"/>
-          </a:p>
-          <a:p>
-            <a:pPr indent="0" marL="0">
-              <a:spcAft>
-                <a:spcPts val="300"/>
-              </a:spcAft>
-              <a:buNone/>
-            </a:pPr>
-            <a:r>
-              <a:rPr lang="en-US" sz="1250" dirty="0">
-                <a:solidFill>
-                  <a:schemeClr val="tx1"/>
-                </a:solidFill>
-              </a:rPr>
-              <a:t>β (průměrný účinek intervence): prior z metaanalýz</a:t>
-            </a:r>
-            <a:endParaRPr lang="en-US" sz="1550" dirty="0"/>
-          </a:p>
-        </p:txBody>
-      </p:sp>
-      <p:sp>
-        <p:nvSpPr>
-          <p:cNvPr id="7" name="bayes"/>
-          <p:cNvSpPr/>
-          <p:nvPr/>
-        </p:nvSpPr>
-        <p:spPr>
-          <a:xfrm>
-            <a:off x="3886200" y="1234440"/>
-            <a:ext cx="4160520" cy="2606040"/>
-          </a:xfrm>
-          <a:prstGeom prst="roundRect">
-            <a:avLst>
-              <a:gd name="adj" fmla="val 2807"/>
-            </a:avLst>
-          </a:prstGeom>
-          <a:solidFill>
-            <a:schemeClr val="accent1"/>
-          </a:solidFill>
-          <a:ln/>
-        </p:spPr>
-      </p:sp>
-      <p:sp>
-        <p:nvSpPr>
-          <p:cNvPr id="8" name="bayes_text"/>
-          <p:cNvSpPr txBox="1"/>
-          <p:nvPr/>
-        </p:nvSpPr>
-        <p:spPr>
-          <a:xfrm>
-            <a:off x="4114800" y="1399032"/>
-            <a:ext cx="3703320" cy="2331720"/>
-          </a:xfrm>
-          <a:prstGeom prst="rect">
-            <a:avLst/>
-          </a:prstGeom>
-          <a:noFill/>
-          <a:ln/>
-        </p:spPr>
-        <p:txBody>
-          <a:bodyPr wrap="square" lIns="0" tIns="0" rIns="0" bIns="0" rtlCol="0" anchor="t"/>
-          <a:lstStyle/>
-          <a:p>
-            <a:pPr indent="0" marL="0">
-              <a:spcAft>
-                <a:spcPts val="600"/>
-              </a:spcAft>
-              <a:buNone/>
-            </a:pPr>
-            <a:r>
-              <a:rPr lang="en-US" sz="1600" b="1" dirty="0">
-                <a:solidFill>
-                  <a:schemeClr val="bg1"/>
-                </a:solidFill>
-              </a:rPr>
-              <a:t>Bayesovský hierarchický model</a:t>
-            </a:r>
-            <a:endParaRPr lang="en-US" sz="1600" dirty="0"/>
-          </a:p>
-          <a:p>
-            <a:pPr indent="0" marL="0">
-              <a:buNone/>
-            </a:pPr>
-            <a:r>
-              <a:rPr lang="en-US" sz="1800" dirty="0">
-                <a:solidFill>
-                  <a:schemeClr val="bg1"/>
-                </a:solidFill>
-              </a:rPr>
-              <a:t>logit P(účast | x, k) = f(x) + β</a:t>
-            </a:r>
-            <a:r>
-              <a:rPr lang="en-US" sz="1800" baseline="-40000" dirty="0">
-                <a:solidFill>
-                  <a:schemeClr val="bg1"/>
-                </a:solidFill>
-              </a:rPr>
-              <a:t>k</a:t>
-            </a:r>
-            <a:r>
-              <a:rPr lang="en-US" sz="1800" dirty="0">
-                <a:solidFill>
-                  <a:schemeClr val="bg1"/>
-                </a:solidFill>
-              </a:rPr>
-              <a:t> + g</a:t>
-            </a:r>
-            <a:r>
-              <a:rPr lang="en-US" sz="1800" baseline="-40000" dirty="0">
-                <a:solidFill>
-                  <a:schemeClr val="bg1"/>
-                </a:solidFill>
-              </a:rPr>
-              <a:t>k</a:t>
-            </a:r>
-            <a:r>
-              <a:rPr lang="en-US" sz="1800" dirty="0">
-                <a:solidFill>
-                  <a:schemeClr val="bg1"/>
-                </a:solidFill>
-              </a:rPr>
-              <a:t>(x)</a:t>
-            </a:r>
-            <a:endParaRPr lang="en-US" sz="1600" dirty="0"/>
-          </a:p>
-          <a:p>
-            <a:pPr indent="0" marL="0">
-              <a:buNone/>
-            </a:pPr>
-            <a:r>
-              <a:rPr lang="en-US" sz="1800" dirty="0">
-                <a:solidFill>
-                  <a:schemeClr val="bg1"/>
-                </a:solidFill>
-              </a:rPr>
-              <a:t>τ</a:t>
-            </a:r>
-            <a:r>
-              <a:rPr lang="en-US" sz="1800" baseline="-40000" dirty="0">
-                <a:solidFill>
-                  <a:schemeClr val="bg1"/>
-                </a:solidFill>
-              </a:rPr>
-              <a:t>k</a:t>
-            </a:r>
-            <a:r>
-              <a:rPr lang="en-US" sz="1800" dirty="0">
-                <a:solidFill>
-                  <a:schemeClr val="bg1"/>
-                </a:solidFill>
-              </a:rPr>
-              <a:t>(x) = σ(f + β</a:t>
-            </a:r>
-            <a:r>
-              <a:rPr lang="en-US" sz="1800" baseline="-40000" dirty="0">
-                <a:solidFill>
-                  <a:schemeClr val="bg1"/>
-                </a:solidFill>
-              </a:rPr>
-              <a:t>k</a:t>
-            </a:r>
-            <a:r>
-              <a:rPr lang="en-US" sz="1800" dirty="0">
-                <a:solidFill>
-                  <a:schemeClr val="bg1"/>
-                </a:solidFill>
-              </a:rPr>
-              <a:t> + g</a:t>
-            </a:r>
-            <a:r>
-              <a:rPr lang="en-US" sz="1800" baseline="-40000" dirty="0">
-                <a:solidFill>
-                  <a:schemeClr val="bg1"/>
-                </a:solidFill>
-              </a:rPr>
-              <a:t>k</a:t>
-            </a:r>
-            <a:r>
-              <a:rPr lang="en-US" sz="1800" dirty="0">
-                <a:solidFill>
-                  <a:schemeClr val="bg1"/>
-                </a:solidFill>
-              </a:rPr>
-              <a:t>) − σ(f)</a:t>
-            </a:r>
-            <a:endParaRPr lang="en-US" sz="1600" dirty="0"/>
-          </a:p>
-          <a:p>
-            <a:pPr indent="0" marL="0">
-              <a:buNone/>
-            </a:pPr>
-            <a:r>
-              <a:rPr lang="en-US" sz="1350" dirty="0">
-                <a:solidFill>
-                  <a:schemeClr val="accent3"/>
-                </a:solidFill>
-              </a:rPr>
-              <a:t>g</a:t>
-            </a:r>
-            <a:r>
-              <a:rPr lang="en-US" sz="1350" baseline="-40000" dirty="0">
-                <a:solidFill>
-                  <a:schemeClr val="accent3"/>
-                </a:solidFill>
-              </a:rPr>
-              <a:t>k</a:t>
-            </a:r>
-            <a:r>
-              <a:rPr lang="en-US" sz="1350" dirty="0">
-                <a:solidFill>
-                  <a:schemeClr val="accent3"/>
-                </a:solidFill>
-              </a:rPr>
-              <a:t>(x): rozdíly v účinku mezi klienty na stejných znacích jako EBM, prior smrštěný k nule. Uplift je malý u těch, kdo přijdou vždy nebo nikdy, největší uprostřed.</a:t>
-            </a:r>
-            <a:endParaRPr lang="en-US" sz="1600" dirty="0"/>
-          </a:p>
-        </p:txBody>
-      </p:sp>
-      <p:sp>
-        <p:nvSpPr>
-          <p:cNvPr id="9" name="experimenty"/>
-          <p:cNvSpPr/>
-          <p:nvPr/>
-        </p:nvSpPr>
-        <p:spPr>
-          <a:xfrm>
-            <a:off x="8641080" y="1234440"/>
-            <a:ext cx="3001975" cy="1188720"/>
-          </a:xfrm>
-          <a:prstGeom prst="roundRect">
-            <a:avLst>
-              <a:gd name="adj" fmla="val 6154"/>
-            </a:avLst>
-          </a:prstGeom>
-          <a:solidFill>
-            <a:schemeClr val="bg2"/>
-          </a:solidFill>
-          <a:ln/>
-        </p:spPr>
-      </p:sp>
-      <p:sp>
-        <p:nvSpPr>
-          <p:cNvPr id="10" name="experimenty_text"/>
-          <p:cNvSpPr txBox="1"/>
-          <p:nvPr/>
-        </p:nvSpPr>
-        <p:spPr>
-          <a:xfrm>
-            <a:off x="8805672" y="1366114"/>
-            <a:ext cx="2672791" cy="925373"/>
-          </a:xfrm>
-          <a:prstGeom prst="rect">
-            <a:avLst/>
-          </a:prstGeom>
-          <a:noFill/>
-          <a:ln/>
-        </p:spPr>
-        <p:txBody>
-          <a:bodyPr wrap="square" lIns="0" tIns="0" rIns="0" bIns="0" rtlCol="0" anchor="t"/>
-          <a:lstStyle/>
-          <a:p>
-            <a:pPr indent="0" marL="0">
-              <a:spcAft>
-                <a:spcPts val="400"/>
-              </a:spcAft>
-              <a:buNone/>
-            </a:pPr>
-            <a:r>
-              <a:rPr lang="en-US" sz="1550" b="1" dirty="0">
-                <a:solidFill>
-                  <a:schemeClr val="accent1"/>
-                </a:solidFill>
-              </a:rPr>
-              <a:t>Randomizované pokusy</a:t>
-            </a:r>
-            <a:endParaRPr lang="en-US" sz="1550" dirty="0"/>
-          </a:p>
-          <a:p>
-            <a:pPr indent="0" marL="0">
-              <a:buNone/>
-            </a:pPr>
-            <a:r>
-              <a:rPr lang="en-US" sz="1250" dirty="0">
-                <a:solidFill>
-                  <a:schemeClr val="tx1"/>
-                </a:solidFill>
-              </a:rPr>
-              <a:t>zaznamenaná pravděpodobnost přiřazení → </a:t>
-            </a:r>
-            <a:r>
-              <a:rPr lang="en-US" sz="1250" b="1" dirty="0">
-                <a:solidFill>
-                  <a:schemeClr val="tx1"/>
-                </a:solidFill>
-              </a:rPr>
-              <a:t>posterior</a:t>
-            </a:r>
-            <a:endParaRPr lang="en-US" sz="1550" dirty="0"/>
-          </a:p>
-        </p:txBody>
-      </p:sp>
-      <p:sp>
-        <p:nvSpPr>
-          <p:cNvPr id="11" name="rozhodnuti"/>
-          <p:cNvSpPr/>
-          <p:nvPr/>
-        </p:nvSpPr>
-        <p:spPr>
-          <a:xfrm>
-            <a:off x="8641080" y="2651760"/>
-            <a:ext cx="3001975" cy="1188720"/>
-          </a:xfrm>
-          <a:prstGeom prst="roundRect">
-            <a:avLst>
-              <a:gd name="adj" fmla="val 6154"/>
-            </a:avLst>
-          </a:prstGeom>
-          <a:solidFill>
-            <a:schemeClr val="bg2"/>
-          </a:solidFill>
-          <a:ln/>
-        </p:spPr>
-      </p:sp>
-      <p:sp>
-        <p:nvSpPr>
-          <p:cNvPr id="12" name="rozhodnuti_text"/>
-          <p:cNvSpPr txBox="1"/>
-          <p:nvPr/>
-        </p:nvSpPr>
-        <p:spPr>
-          <a:xfrm>
-            <a:off x="8805672" y="2783434"/>
-            <a:ext cx="2672791" cy="925373"/>
-          </a:xfrm>
-          <a:prstGeom prst="rect">
-            <a:avLst/>
-          </a:prstGeom>
-          <a:noFill/>
-          <a:ln/>
-        </p:spPr>
-        <p:txBody>
-          <a:bodyPr wrap="square" lIns="0" tIns="0" rIns="0" bIns="0" rtlCol="0" anchor="t"/>
-          <a:lstStyle/>
-          <a:p>
-            <a:pPr indent="0" marL="0">
-              <a:spcAft>
-                <a:spcPts val="400"/>
-              </a:spcAft>
-              <a:buNone/>
-            </a:pPr>
-            <a:r>
-              <a:rPr lang="en-US" sz="1550" b="1" dirty="0">
-                <a:solidFill>
-                  <a:schemeClr val="accent1"/>
-                </a:solidFill>
-              </a:rPr>
-              <a:t>Rozhodnutí</a:t>
-            </a:r>
-            <a:endParaRPr lang="en-US" sz="1550" dirty="0"/>
-          </a:p>
-          <a:p>
-            <a:pPr indent="0" marL="0">
-              <a:buNone/>
-            </a:pPr>
-            <a:r>
-              <a:rPr lang="en-US" sz="1250" dirty="0">
-                <a:solidFill>
-                  <a:schemeClr val="tx1"/>
-                </a:solidFill>
-              </a:rPr>
-              <a:t>τ × zdravotní přínos − náklad, v mezích rozpočtu, kapacit a rovnosti</a:t>
-            </a:r>
-            <a:endParaRPr lang="en-US" sz="1550" dirty="0"/>
-          </a:p>
-        </p:txBody>
-      </p:sp>
-      <p:sp>
-        <p:nvSpPr>
-          <p:cNvPr id="13" name="sip_ebm"/>
-          <p:cNvSpPr/>
-          <p:nvPr/>
-        </p:nvSpPr>
-        <p:spPr>
-          <a:xfrm>
-            <a:off x="3291840" y="1828800"/>
-            <a:ext cx="594360" cy="0"/>
-          </a:xfrm>
-          <a:prstGeom prst="line">
-            <a:avLst/>
-          </a:prstGeom>
-          <a:noFill/>
-          <a:ln w="25400">
-            <a:solidFill>
-              <a:srgbClr val="3D4F5C"/>
-            </a:solidFill>
-            <a:prstDash val="solid"/>
-            <a:tailEnd type="triangle"/>
-          </a:ln>
-        </p:spPr>
-      </p:sp>
-      <p:sp>
-        <p:nvSpPr>
-          <p:cNvPr id="14" name="sip_lit"/>
-          <p:cNvSpPr/>
-          <p:nvPr/>
-        </p:nvSpPr>
-        <p:spPr>
-          <a:xfrm>
-            <a:off x="3291840" y="3246120"/>
-            <a:ext cx="594360" cy="0"/>
-          </a:xfrm>
-          <a:prstGeom prst="line">
-            <a:avLst/>
-          </a:prstGeom>
-          <a:noFill/>
-          <a:ln w="25400">
-            <a:solidFill>
-              <a:srgbClr val="3D4F5C"/>
-            </a:solidFill>
-            <a:prstDash val="solid"/>
-            <a:tailEnd type="triangle"/>
-          </a:ln>
-        </p:spPr>
-      </p:sp>
-      <p:sp>
-        <p:nvSpPr>
-          <p:cNvPr id="15" name="sip_exp"/>
-          <p:cNvSpPr/>
-          <p:nvPr/>
-        </p:nvSpPr>
-        <p:spPr>
-          <a:xfrm>
-            <a:off x="8046720" y="1828800"/>
-            <a:ext cx="594360" cy="0"/>
-          </a:xfrm>
-          <a:prstGeom prst="line">
-            <a:avLst/>
-          </a:prstGeom>
-          <a:noFill/>
-          <a:ln w="25400">
-            <a:solidFill>
-              <a:srgbClr val="3D4F5C"/>
-            </a:solidFill>
-            <a:prstDash val="solid"/>
-            <a:headEnd type="triangle"/>
-          </a:ln>
-        </p:spPr>
-      </p:sp>
-      <p:sp>
-        <p:nvSpPr>
-          <p:cNvPr id="16" name="sip_rozh"/>
-          <p:cNvSpPr/>
-          <p:nvPr/>
-        </p:nvSpPr>
-        <p:spPr>
-          <a:xfrm>
-            <a:off x="8046720" y="3246120"/>
-            <a:ext cx="594360" cy="0"/>
-          </a:xfrm>
-          <a:prstGeom prst="line">
-            <a:avLst/>
-          </a:prstGeom>
-          <a:noFill/>
-          <a:ln w="25400">
-            <a:solidFill>
-              <a:srgbClr val="3D4F5C"/>
-            </a:solidFill>
-            <a:prstDash val="solid"/>
-            <a:tailEnd type="triangle"/>
-          </a:ln>
-        </p:spPr>
-      </p:sp>
-      <p:sp>
-        <p:nvSpPr>
-          <p:cNvPr id="17" name="sip_pruzkum"/>
-          <p:cNvSpPr/>
-          <p:nvPr/>
-        </p:nvSpPr>
-        <p:spPr>
-          <a:xfrm>
-            <a:off x="10142068" y="2423160"/>
-            <a:ext cx="0" cy="228600"/>
-          </a:xfrm>
-          <a:prstGeom prst="line">
-            <a:avLst/>
-          </a:prstGeom>
-          <a:noFill/>
-          <a:ln w="25400">
-            <a:solidFill>
-              <a:srgbClr val="3D4F5C"/>
-            </a:solidFill>
-            <a:prstDash val="solid"/>
-            <a:headEnd type="triangle"/>
-          </a:ln>
-        </p:spPr>
-      </p:sp>
-      <p:sp>
-        <p:nvSpPr>
-          <p:cNvPr id="18" name="sip_pruzkum_popis"/>
-          <p:cNvSpPr txBox="1"/>
-          <p:nvPr/>
-        </p:nvSpPr>
-        <p:spPr>
-          <a:xfrm>
-            <a:off x="10233508" y="2400300"/>
-            <a:ext cx="1463040" cy="274320"/>
-          </a:xfrm>
-          <a:prstGeom prst="rect">
-            <a:avLst/>
-          </a:prstGeom>
-          <a:noFill/>
-          <a:ln/>
-        </p:spPr>
-        <p:txBody>
-          <a:bodyPr wrap="square" lIns="0" tIns="0" rIns="0" bIns="0" rtlCol="0" anchor="t"/>
-          <a:lstStyle/>
-          <a:p>
-            <a:pPr indent="0" marL="0">
-              <a:buNone/>
-            </a:pPr>
-            <a:r>
-              <a:rPr lang="en-US" sz="1100" i="1" dirty="0">
+              <a:buNone/>
+            </a:pPr>
+            <a:r>
+              <a:rPr lang="en-US" sz="1100" b="1" dirty="0">
                 <a:solidFill>
                   <a:schemeClr val="accent4"/>
                 </a:solidFill>
               </a:rPr>
-              <a:t>průzkum ~10 %</a:t>
+              <a:t>Zvážené alternativy:</a:t>
+            </a:r>
+            <a:r>
+              <a:rPr lang="en-US" sz="1100" dirty="0">
+                <a:solidFill>
+                  <a:schemeClr val="accent4"/>
+                </a:solidFill>
+              </a:rPr>
+              <a:t> logit se splajny (málo pružný), skórkarta (méně přesná), GBM + SHAP (jen dodatečné vysvětlení; zůstává jako měřítko ceny vysvětlitelnosti).</a:t>
             </a:r>
             <a:endParaRPr lang="en-US" sz="1100" dirty="0"/>
-          </a:p>
-        </p:txBody>
-      </p:sp>
-      <p:sp>
-        <p:nvSpPr>
-          <p:cNvPr id="19" name="pozdeji"/>
-          <p:cNvSpPr/>
-          <p:nvPr/>
-        </p:nvSpPr>
-        <p:spPr>
-          <a:xfrm>
-            <a:off x="3886200" y="4023360"/>
-            <a:ext cx="4160520" cy="502920"/>
-          </a:xfrm>
-          <a:prstGeom prst="roundRect">
-            <a:avLst>
-              <a:gd name="adj" fmla="val 14545"/>
-            </a:avLst>
-          </a:prstGeom>
-          <a:solidFill>
-            <a:schemeClr val="bg1"/>
-          </a:solidFill>
-          <a:ln w="12700">
-            <a:solidFill>
-              <a:srgbClr val="3D4F5C"/>
-            </a:solidFill>
-            <a:prstDash val="dash"/>
-          </a:ln>
-        </p:spPr>
-      </p:sp>
-      <p:sp>
-        <p:nvSpPr>
-          <p:cNvPr id="20" name="pozdeji_text"/>
-          <p:cNvSpPr txBox="1"/>
-          <p:nvPr/>
-        </p:nvSpPr>
-        <p:spPr>
-          <a:xfrm>
-            <a:off x="4023360" y="4096512"/>
-            <a:ext cx="3886200" cy="365760"/>
-          </a:xfrm>
-          <a:prstGeom prst="rect">
-            <a:avLst/>
-          </a:prstGeom>
-          <a:noFill/>
-          <a:ln/>
-        </p:spPr>
-        <p:txBody>
-          <a:bodyPr wrap="square" lIns="0" tIns="0" rIns="0" bIns="0" rtlCol="0" anchor="ctr"/>
-          <a:lstStyle/>
-          <a:p>
-            <a:pPr indent="0" marL="0">
-              <a:buNone/>
-            </a:pPr>
-            <a:r>
-              <a:rPr lang="en-US" sz="1200" b="1" dirty="0">
-                <a:solidFill>
-                  <a:schemeClr val="accent4"/>
-                </a:solidFill>
-              </a:rPr>
-              <a:t>Později, s dostatkem dat:</a:t>
-            </a:r>
-            <a:r>
-              <a:rPr lang="en-US" sz="1200" dirty="0">
-                <a:solidFill>
-                  <a:schemeClr val="accent4"/>
-                </a:solidFill>
-              </a:rPr>
-              <a:t> DR-learner + causal forest</a:t>
-            </a:r>
-            <a:endParaRPr lang="en-US" sz="1200" dirty="0"/>
-          </a:p>
-        </p:txBody>
-      </p:sp>
-      <p:sp>
-        <p:nvSpPr>
-          <p:cNvPr id="21" name="proc_randomizace"/>
-          <p:cNvSpPr/>
-          <p:nvPr/>
-        </p:nvSpPr>
-        <p:spPr>
-          <a:xfrm>
-            <a:off x="548640" y="4754880"/>
-            <a:ext cx="3545738" cy="1600200"/>
-          </a:xfrm>
-          <a:prstGeom prst="roundRect">
-            <a:avLst>
-              <a:gd name="adj" fmla="val 4571"/>
-            </a:avLst>
-          </a:prstGeom>
-          <a:solidFill>
-            <a:schemeClr val="bg2"/>
-          </a:solidFill>
-          <a:ln/>
-        </p:spPr>
-      </p:sp>
-      <p:sp>
-        <p:nvSpPr>
-          <p:cNvPr id="22" name="proc_randomizace_text"/>
-          <p:cNvSpPr txBox="1"/>
-          <p:nvPr/>
-        </p:nvSpPr>
-        <p:spPr>
-          <a:xfrm>
-            <a:off x="713232" y="4886554"/>
-            <a:ext cx="3216554" cy="1336853"/>
-          </a:xfrm>
-          <a:prstGeom prst="rect">
-            <a:avLst/>
-          </a:prstGeom>
-          <a:noFill/>
-          <a:ln/>
-        </p:spPr>
-        <p:txBody>
-          <a:bodyPr wrap="square" lIns="0" tIns="0" rIns="0" bIns="0" rtlCol="0" anchor="t"/>
-          <a:lstStyle/>
-          <a:p>
-            <a:pPr indent="0" marL="0">
-              <a:spcAft>
-                <a:spcPts val="400"/>
-              </a:spcAft>
-              <a:buNone/>
-            </a:pPr>
-            <a:r>
-              <a:rPr lang="en-US" sz="1550" b="1" dirty="0">
-                <a:solidFill>
-                  <a:schemeClr val="accent1"/>
-                </a:solidFill>
-              </a:rPr>
-              <a:t>Proč randomizace</a:t>
-            </a:r>
-            <a:endParaRPr lang="en-US" sz="1550" dirty="0"/>
-          </a:p>
-          <a:p>
-            <a:pPr indent="0" marL="0">
-              <a:buNone/>
-            </a:pPr>
-            <a:r>
-              <a:rPr lang="en-US" sz="1250" dirty="0">
-                <a:solidFill>
-                  <a:schemeClr val="tx1"/>
-                </a:solidFill>
-              </a:rPr>
-              <a:t>Data VZP ukážou, </a:t>
-            </a:r>
-            <a:r>
-              <a:rPr lang="en-US" sz="1250" b="1" dirty="0">
-                <a:solidFill>
-                  <a:schemeClr val="tx1"/>
-                </a:solidFill>
-              </a:rPr>
-              <a:t>kdo přichází</a:t>
-            </a:r>
-            <a:r>
-              <a:rPr lang="en-US" sz="1250" dirty="0">
-                <a:solidFill>
-                  <a:schemeClr val="tx1"/>
-                </a:solidFill>
-              </a:rPr>
-              <a:t>, ale ne </a:t>
-            </a:r>
-            <a:r>
-              <a:rPr lang="en-US" sz="1250" b="1" dirty="0">
-                <a:solidFill>
-                  <a:schemeClr val="tx1"/>
-                </a:solidFill>
-              </a:rPr>
-              <a:t>kdo přijde díky intervenci</a:t>
-            </a:r>
-            <a:r>
-              <a:rPr lang="en-US" sz="1250" dirty="0">
-                <a:solidFill>
-                  <a:schemeClr val="tx1"/>
-                </a:solidFill>
-              </a:rPr>
-              <a:t>: kanály nikdy nebyly přidělené náhodně. Uplift se proto učí z pokusů.</a:t>
-            </a:r>
-            <a:endParaRPr lang="en-US" sz="1550" dirty="0"/>
-          </a:p>
-        </p:txBody>
-      </p:sp>
-      <p:sp>
-        <p:nvSpPr>
-          <p:cNvPr id="23" name="vyhodnoceni"/>
-          <p:cNvSpPr/>
-          <p:nvPr/>
-        </p:nvSpPr>
-        <p:spPr>
-          <a:xfrm>
-            <a:off x="4322978" y="4754880"/>
-            <a:ext cx="3545738" cy="1600200"/>
-          </a:xfrm>
-          <a:prstGeom prst="roundRect">
-            <a:avLst>
-              <a:gd name="adj" fmla="val 4571"/>
-            </a:avLst>
-          </a:prstGeom>
-          <a:solidFill>
-            <a:schemeClr val="bg2"/>
-          </a:solidFill>
-          <a:ln/>
-        </p:spPr>
-      </p:sp>
-      <p:sp>
-        <p:nvSpPr>
-          <p:cNvPr id="24" name="vyhodnoceni_text"/>
-          <p:cNvSpPr txBox="1"/>
-          <p:nvPr/>
-        </p:nvSpPr>
-        <p:spPr>
-          <a:xfrm>
-            <a:off x="4487570" y="4886554"/>
-            <a:ext cx="3216554" cy="1336853"/>
-          </a:xfrm>
-          <a:prstGeom prst="rect">
-            <a:avLst/>
-          </a:prstGeom>
-          <a:noFill/>
-          <a:ln/>
-        </p:spPr>
-        <p:txBody>
-          <a:bodyPr wrap="square" lIns="0" tIns="0" rIns="0" bIns="0" rtlCol="0" anchor="t"/>
-          <a:lstStyle/>
-          <a:p>
-            <a:pPr indent="0" marL="0">
-              <a:spcAft>
-                <a:spcPts val="400"/>
-              </a:spcAft>
-              <a:buNone/>
-            </a:pPr>
-            <a:r>
-              <a:rPr lang="en-US" sz="1550" b="1" dirty="0">
-                <a:solidFill>
-                  <a:schemeClr val="accent1"/>
-                </a:solidFill>
-              </a:rPr>
-              <a:t>Vyhodnocení</a:t>
-            </a:r>
-            <a:endParaRPr lang="en-US" sz="1550" dirty="0"/>
-          </a:p>
-          <a:p>
-            <a:pPr indent="0" marL="0">
-              <a:buNone/>
-            </a:pPr>
-            <a:r>
-              <a:rPr lang="en-US" sz="1250" dirty="0">
-                <a:solidFill>
-                  <a:schemeClr val="tx1"/>
-                </a:solidFill>
-              </a:rPr>
-              <a:t>Qini / AUUC a kalibrace upliftu po decilech, hodnota pravidla cílení off-policy (DR), </a:t>
-            </a:r>
-            <a:r>
-              <a:rPr lang="en-US" sz="1250" b="1" dirty="0">
-                <a:solidFill>
-                  <a:schemeClr val="tx1"/>
-                </a:solidFill>
-              </a:rPr>
-              <a:t>trvalá kontrolní skupina</a:t>
-            </a:r>
-            <a:r>
-              <a:rPr lang="en-US" sz="1250" dirty="0">
-                <a:solidFill>
-                  <a:schemeClr val="tx1"/>
-                </a:solidFill>
-              </a:rPr>
-              <a:t>.</a:t>
-            </a:r>
-            <a:endParaRPr lang="en-US" sz="1550" dirty="0"/>
-          </a:p>
-        </p:txBody>
-      </p:sp>
-      <p:sp>
-        <p:nvSpPr>
-          <p:cNvPr id="25" name="rizika"/>
-          <p:cNvSpPr/>
-          <p:nvPr/>
-        </p:nvSpPr>
-        <p:spPr>
-          <a:xfrm>
-            <a:off x="8097317" y="4754880"/>
-            <a:ext cx="3545738" cy="1600200"/>
-          </a:xfrm>
-          <a:prstGeom prst="roundRect">
-            <a:avLst>
-              <a:gd name="adj" fmla="val 4571"/>
-            </a:avLst>
-          </a:prstGeom>
-          <a:solidFill>
-            <a:schemeClr val="bg2"/>
-          </a:solidFill>
-          <a:ln/>
-        </p:spPr>
-      </p:sp>
-      <p:sp>
-        <p:nvSpPr>
-          <p:cNvPr id="26" name="rizika_text"/>
-          <p:cNvSpPr txBox="1"/>
-          <p:nvPr/>
-        </p:nvSpPr>
-        <p:spPr>
-          <a:xfrm>
-            <a:off x="8261909" y="4886554"/>
-            <a:ext cx="3216554" cy="1336853"/>
-          </a:xfrm>
-          <a:prstGeom prst="rect">
-            <a:avLst/>
-          </a:prstGeom>
-          <a:noFill/>
-          <a:ln/>
-        </p:spPr>
-        <p:txBody>
-          <a:bodyPr wrap="square" lIns="0" tIns="0" rIns="0" bIns="0" rtlCol="0" anchor="t"/>
-          <a:lstStyle/>
-          <a:p>
-            <a:pPr indent="0" marL="0">
-              <a:spcAft>
-                <a:spcPts val="400"/>
-              </a:spcAft>
-              <a:buNone/>
-            </a:pPr>
-            <a:r>
-              <a:rPr lang="en-US" sz="1550" b="1" dirty="0">
-                <a:solidFill>
-                  <a:schemeClr val="accent1"/>
-                </a:solidFill>
-              </a:rPr>
-              <a:t>Rizika</a:t>
-            </a:r>
-            <a:endParaRPr lang="en-US" sz="1550" dirty="0"/>
-          </a:p>
-          <a:p>
-            <a:pPr indent="0" marL="0">
-              <a:buNone/>
-            </a:pPr>
-            <a:r>
-              <a:rPr lang="en-US" sz="1250" dirty="0">
-                <a:solidFill>
-                  <a:schemeClr val="tx1"/>
-                </a:solidFill>
-              </a:rPr>
-              <a:t>Negativní uplift („sleeping dogs“), pořadí kanálů (dopis → SMS → telefonát), posun v čase, férovost.</a:t>
-            </a:r>
-            <a:endParaRPr lang="en-US" sz="1550" dirty="0"/>
           </a:p>
         </p:txBody>
       </p:sp>
@@ -6038,6 +5913,1132 @@
             <a:r>
               <a:rPr lang="en-US" sz="3000" b="1" dirty="0">
                 <a:solidFill>
+                  <a:schemeClr val="accent1"/>
+                </a:solidFill>
+              </a:rPr>
+              <a:t>Model upliftu: bayesovský, s modelem účasti jako priorem</a:t>
+            </a:r>
+            <a:endParaRPr lang="en-US" sz="3000" dirty="0"/>
+          </a:p>
+        </p:txBody>
+      </p:sp>
+      <p:sp>
+        <p:nvSpPr>
+          <p:cNvPr id="3" name="prior_ebm"/>
+          <p:cNvSpPr/>
+          <p:nvPr/>
+        </p:nvSpPr>
+        <p:spPr>
+          <a:xfrm>
+            <a:off x="548640" y="1234440"/>
+            <a:ext cx="2743200" cy="1188720"/>
+          </a:xfrm>
+          <a:prstGeom prst="roundRect">
+            <a:avLst>
+              <a:gd name="adj" fmla="val 6154"/>
+            </a:avLst>
+          </a:prstGeom>
+          <a:solidFill>
+            <a:schemeClr val="bg2"/>
+          </a:solidFill>
+          <a:ln/>
+        </p:spPr>
+      </p:sp>
+      <p:sp>
+        <p:nvSpPr>
+          <p:cNvPr id="4" name="prior_ebm_text"/>
+          <p:cNvSpPr txBox="1"/>
+          <p:nvPr/>
+        </p:nvSpPr>
+        <p:spPr>
+          <a:xfrm>
+            <a:off x="713232" y="1366114"/>
+            <a:ext cx="2414016" cy="925373"/>
+          </a:xfrm>
+          <a:prstGeom prst="rect">
+            <a:avLst/>
+          </a:prstGeom>
+          <a:noFill/>
+          <a:ln/>
+        </p:spPr>
+        <p:txBody>
+          <a:bodyPr wrap="square" lIns="0" tIns="0" rIns="0" bIns="0" rtlCol="0" anchor="t"/>
+          <a:lstStyle/>
+          <a:p>
+            <a:pPr indent="0" marL="0">
+              <a:spcAft>
+                <a:spcPts val="400"/>
+              </a:spcAft>
+              <a:buNone/>
+            </a:pPr>
+            <a:r>
+              <a:rPr lang="en-US" sz="1550" b="1" dirty="0">
+                <a:solidFill>
+                  <a:schemeClr val="accent1"/>
+                </a:solidFill>
+              </a:rPr>
+              <a:t>Model účasti (EBM)</a:t>
+            </a:r>
+            <a:endParaRPr lang="en-US" sz="1550" dirty="0"/>
+          </a:p>
+          <a:p>
+            <a:pPr indent="0" marL="0">
+              <a:buNone/>
+            </a:pPr>
+            <a:r>
+              <a:rPr lang="en-US" sz="1250" dirty="0">
+                <a:solidFill>
+                  <a:schemeClr val="tx1"/>
+                </a:solidFill>
+              </a:rPr>
+              <a:t>f(x): výchozí logit klienta, </a:t>
+            </a:r>
+            <a:r>
+              <a:rPr lang="en-US" sz="1250" b="1" dirty="0">
+                <a:solidFill>
+                  <a:schemeClr val="tx1"/>
+                </a:solidFill>
+              </a:rPr>
+              <a:t>prior pro uplift</a:t>
+            </a:r>
+            <a:endParaRPr lang="en-US" sz="1550" dirty="0"/>
+          </a:p>
+        </p:txBody>
+      </p:sp>
+      <p:sp>
+        <p:nvSpPr>
+          <p:cNvPr id="5" name="prior_literatura"/>
+          <p:cNvSpPr/>
+          <p:nvPr/>
+        </p:nvSpPr>
+        <p:spPr>
+          <a:xfrm>
+            <a:off x="548640" y="2651760"/>
+            <a:ext cx="2743200" cy="1188720"/>
+          </a:xfrm>
+          <a:prstGeom prst="roundRect">
+            <a:avLst>
+              <a:gd name="adj" fmla="val 6154"/>
+            </a:avLst>
+          </a:prstGeom>
+          <a:solidFill>
+            <a:schemeClr val="bg2"/>
+          </a:solidFill>
+          <a:ln/>
+        </p:spPr>
+      </p:sp>
+      <p:sp>
+        <p:nvSpPr>
+          <p:cNvPr id="6" name="prior_literatura_text"/>
+          <p:cNvSpPr txBox="1"/>
+          <p:nvPr/>
+        </p:nvSpPr>
+        <p:spPr>
+          <a:xfrm>
+            <a:off x="713232" y="2783434"/>
+            <a:ext cx="2414016" cy="925373"/>
+          </a:xfrm>
+          <a:prstGeom prst="rect">
+            <a:avLst/>
+          </a:prstGeom>
+          <a:noFill/>
+          <a:ln/>
+        </p:spPr>
+        <p:txBody>
+          <a:bodyPr wrap="square" lIns="0" tIns="0" rIns="0" bIns="0" rtlCol="0" anchor="t"/>
+          <a:lstStyle/>
+          <a:p>
+            <a:pPr indent="0" marL="0">
+              <a:spcAft>
+                <a:spcPts val="400"/>
+              </a:spcAft>
+              <a:buNone/>
+            </a:pPr>
+            <a:r>
+              <a:rPr lang="en-US" sz="1550" b="1" dirty="0">
+                <a:solidFill>
+                  <a:schemeClr val="accent1"/>
+                </a:solidFill>
+              </a:rPr>
+              <a:t>Literatura</a:t>
+            </a:r>
+            <a:endParaRPr lang="en-US" sz="1550" dirty="0"/>
+          </a:p>
+          <a:p>
+            <a:pPr indent="0" marL="0">
+              <a:spcAft>
+                <a:spcPts val="300"/>
+              </a:spcAft>
+              <a:buNone/>
+            </a:pPr>
+            <a:r>
+              <a:rPr lang="en-US" sz="1250" dirty="0">
+                <a:solidFill>
+                  <a:schemeClr val="tx1"/>
+                </a:solidFill>
+              </a:rPr>
+              <a:t>β (průměrný účinek intervence): prior z metaanalýz</a:t>
+            </a:r>
+            <a:endParaRPr lang="en-US" sz="1550" dirty="0"/>
+          </a:p>
+        </p:txBody>
+      </p:sp>
+      <p:sp>
+        <p:nvSpPr>
+          <p:cNvPr id="7" name="bayes"/>
+          <p:cNvSpPr/>
+          <p:nvPr/>
+        </p:nvSpPr>
+        <p:spPr>
+          <a:xfrm>
+            <a:off x="3886200" y="1234440"/>
+            <a:ext cx="4160520" cy="2606040"/>
+          </a:xfrm>
+          <a:prstGeom prst="roundRect">
+            <a:avLst>
+              <a:gd name="adj" fmla="val 2807"/>
+            </a:avLst>
+          </a:prstGeom>
+          <a:solidFill>
+            <a:schemeClr val="accent1"/>
+          </a:solidFill>
+          <a:ln/>
+        </p:spPr>
+      </p:sp>
+      <p:sp>
+        <p:nvSpPr>
+          <p:cNvPr id="8" name="bayes_text"/>
+          <p:cNvSpPr txBox="1"/>
+          <p:nvPr/>
+        </p:nvSpPr>
+        <p:spPr>
+          <a:xfrm>
+            <a:off x="4114800" y="1399032"/>
+            <a:ext cx="3703320" cy="2331720"/>
+          </a:xfrm>
+          <a:prstGeom prst="rect">
+            <a:avLst/>
+          </a:prstGeom>
+          <a:noFill/>
+          <a:ln/>
+        </p:spPr>
+        <p:txBody>
+          <a:bodyPr wrap="square" lIns="0" tIns="0" rIns="0" bIns="0" rtlCol="0" anchor="t"/>
+          <a:lstStyle/>
+          <a:p>
+            <a:pPr indent="0" marL="0">
+              <a:spcAft>
+                <a:spcPts val="600"/>
+              </a:spcAft>
+              <a:buNone/>
+            </a:pPr>
+            <a:r>
+              <a:rPr lang="en-US" sz="1600" b="1" dirty="0">
+                <a:solidFill>
+                  <a:schemeClr val="bg1"/>
+                </a:solidFill>
+              </a:rPr>
+              <a:t>Bayesovský hierarchický model</a:t>
+            </a:r>
+            <a:endParaRPr lang="en-US" sz="1600" dirty="0"/>
+          </a:p>
+          <a:p>
+            <a:pPr indent="0" marL="0">
+              <a:buNone/>
+            </a:pPr>
+            <a:r>
+              <a:rPr lang="en-US" sz="1800" dirty="0">
+                <a:solidFill>
+                  <a:schemeClr val="bg1"/>
+                </a:solidFill>
+              </a:rPr>
+              <a:t>logit P(účast | x, k) = f(x) + β</a:t>
+            </a:r>
+            <a:r>
+              <a:rPr lang="en-US" sz="1800" baseline="-40000" dirty="0">
+                <a:solidFill>
+                  <a:schemeClr val="bg1"/>
+                </a:solidFill>
+              </a:rPr>
+              <a:t>k</a:t>
+            </a:r>
+            <a:r>
+              <a:rPr lang="en-US" sz="1800" dirty="0">
+                <a:solidFill>
+                  <a:schemeClr val="bg1"/>
+                </a:solidFill>
+              </a:rPr>
+              <a:t> + g</a:t>
+            </a:r>
+            <a:r>
+              <a:rPr lang="en-US" sz="1800" baseline="-40000" dirty="0">
+                <a:solidFill>
+                  <a:schemeClr val="bg1"/>
+                </a:solidFill>
+              </a:rPr>
+              <a:t>k</a:t>
+            </a:r>
+            <a:r>
+              <a:rPr lang="en-US" sz="1800" dirty="0">
+                <a:solidFill>
+                  <a:schemeClr val="bg1"/>
+                </a:solidFill>
+              </a:rPr>
+              <a:t>(x)</a:t>
+            </a:r>
+            <a:endParaRPr lang="en-US" sz="1600" dirty="0"/>
+          </a:p>
+          <a:p>
+            <a:pPr indent="0" marL="0">
+              <a:buNone/>
+            </a:pPr>
+            <a:r>
+              <a:rPr lang="en-US" sz="1800" dirty="0">
+                <a:solidFill>
+                  <a:schemeClr val="bg1"/>
+                </a:solidFill>
+              </a:rPr>
+              <a:t>τ</a:t>
+            </a:r>
+            <a:r>
+              <a:rPr lang="en-US" sz="1800" baseline="-40000" dirty="0">
+                <a:solidFill>
+                  <a:schemeClr val="bg1"/>
+                </a:solidFill>
+              </a:rPr>
+              <a:t>k</a:t>
+            </a:r>
+            <a:r>
+              <a:rPr lang="en-US" sz="1800" dirty="0">
+                <a:solidFill>
+                  <a:schemeClr val="bg1"/>
+                </a:solidFill>
+              </a:rPr>
+              <a:t>(x) = σ(f + β</a:t>
+            </a:r>
+            <a:r>
+              <a:rPr lang="en-US" sz="1800" baseline="-40000" dirty="0">
+                <a:solidFill>
+                  <a:schemeClr val="bg1"/>
+                </a:solidFill>
+              </a:rPr>
+              <a:t>k</a:t>
+            </a:r>
+            <a:r>
+              <a:rPr lang="en-US" sz="1800" dirty="0">
+                <a:solidFill>
+                  <a:schemeClr val="bg1"/>
+                </a:solidFill>
+              </a:rPr>
+              <a:t> + g</a:t>
+            </a:r>
+            <a:r>
+              <a:rPr lang="en-US" sz="1800" baseline="-40000" dirty="0">
+                <a:solidFill>
+                  <a:schemeClr val="bg1"/>
+                </a:solidFill>
+              </a:rPr>
+              <a:t>k</a:t>
+            </a:r>
+            <a:r>
+              <a:rPr lang="en-US" sz="1800" dirty="0">
+                <a:solidFill>
+                  <a:schemeClr val="bg1"/>
+                </a:solidFill>
+              </a:rPr>
+              <a:t>) − σ(f)</a:t>
+            </a:r>
+            <a:endParaRPr lang="en-US" sz="1600" dirty="0"/>
+          </a:p>
+          <a:p>
+            <a:pPr indent="0" marL="0">
+              <a:buNone/>
+            </a:pPr>
+            <a:r>
+              <a:rPr lang="en-US" sz="1350" dirty="0">
+                <a:solidFill>
+                  <a:schemeClr val="accent3"/>
+                </a:solidFill>
+              </a:rPr>
+              <a:t>g</a:t>
+            </a:r>
+            <a:r>
+              <a:rPr lang="en-US" sz="1350" baseline="-40000" dirty="0">
+                <a:solidFill>
+                  <a:schemeClr val="accent3"/>
+                </a:solidFill>
+              </a:rPr>
+              <a:t>k</a:t>
+            </a:r>
+            <a:r>
+              <a:rPr lang="en-US" sz="1350" dirty="0">
+                <a:solidFill>
+                  <a:schemeClr val="accent3"/>
+                </a:solidFill>
+              </a:rPr>
+              <a:t>(x): rozdíly v účinku mezi klienty na stejných znacích jako EBM, prior smrštěný k nule. Uplift je malý u těch, kdo přijdou vždy nebo nikdy, největší uprostřed.</a:t>
+            </a:r>
+            <a:endParaRPr lang="en-US" sz="1600" dirty="0"/>
+          </a:p>
+        </p:txBody>
+      </p:sp>
+      <p:sp>
+        <p:nvSpPr>
+          <p:cNvPr id="9" name="experimenty"/>
+          <p:cNvSpPr/>
+          <p:nvPr/>
+        </p:nvSpPr>
+        <p:spPr>
+          <a:xfrm>
+            <a:off x="8641080" y="1234440"/>
+            <a:ext cx="3001975" cy="1188720"/>
+          </a:xfrm>
+          <a:prstGeom prst="roundRect">
+            <a:avLst>
+              <a:gd name="adj" fmla="val 6154"/>
+            </a:avLst>
+          </a:prstGeom>
+          <a:solidFill>
+            <a:schemeClr val="bg2"/>
+          </a:solidFill>
+          <a:ln/>
+        </p:spPr>
+      </p:sp>
+      <p:sp>
+        <p:nvSpPr>
+          <p:cNvPr id="10" name="experimenty_text"/>
+          <p:cNvSpPr txBox="1"/>
+          <p:nvPr/>
+        </p:nvSpPr>
+        <p:spPr>
+          <a:xfrm>
+            <a:off x="8805672" y="1366114"/>
+            <a:ext cx="2672791" cy="925373"/>
+          </a:xfrm>
+          <a:prstGeom prst="rect">
+            <a:avLst/>
+          </a:prstGeom>
+          <a:noFill/>
+          <a:ln/>
+        </p:spPr>
+        <p:txBody>
+          <a:bodyPr wrap="square" lIns="0" tIns="0" rIns="0" bIns="0" rtlCol="0" anchor="t"/>
+          <a:lstStyle/>
+          <a:p>
+            <a:pPr indent="0" marL="0">
+              <a:spcAft>
+                <a:spcPts val="400"/>
+              </a:spcAft>
+              <a:buNone/>
+            </a:pPr>
+            <a:r>
+              <a:rPr lang="en-US" sz="1550" b="1" dirty="0">
+                <a:solidFill>
+                  <a:schemeClr val="accent1"/>
+                </a:solidFill>
+              </a:rPr>
+              <a:t>Randomizované pokusy</a:t>
+            </a:r>
+            <a:endParaRPr lang="en-US" sz="1550" dirty="0"/>
+          </a:p>
+          <a:p>
+            <a:pPr indent="0" marL="0">
+              <a:buNone/>
+            </a:pPr>
+            <a:r>
+              <a:rPr lang="en-US" sz="1250" dirty="0">
+                <a:solidFill>
+                  <a:schemeClr val="tx1"/>
+                </a:solidFill>
+              </a:rPr>
+              <a:t>zaznamenaná pravděpodobnost přiřazení → </a:t>
+            </a:r>
+            <a:r>
+              <a:rPr lang="en-US" sz="1250" b="1" dirty="0">
+                <a:solidFill>
+                  <a:schemeClr val="tx1"/>
+                </a:solidFill>
+              </a:rPr>
+              <a:t>posterior</a:t>
+            </a:r>
+            <a:endParaRPr lang="en-US" sz="1550" dirty="0"/>
+          </a:p>
+        </p:txBody>
+      </p:sp>
+      <p:sp>
+        <p:nvSpPr>
+          <p:cNvPr id="11" name="rozhodnuti"/>
+          <p:cNvSpPr/>
+          <p:nvPr/>
+        </p:nvSpPr>
+        <p:spPr>
+          <a:xfrm>
+            <a:off x="8641080" y="2651760"/>
+            <a:ext cx="3001975" cy="1188720"/>
+          </a:xfrm>
+          <a:prstGeom prst="roundRect">
+            <a:avLst>
+              <a:gd name="adj" fmla="val 6154"/>
+            </a:avLst>
+          </a:prstGeom>
+          <a:solidFill>
+            <a:schemeClr val="bg2"/>
+          </a:solidFill>
+          <a:ln/>
+        </p:spPr>
+      </p:sp>
+      <p:sp>
+        <p:nvSpPr>
+          <p:cNvPr id="12" name="rozhodnuti_text"/>
+          <p:cNvSpPr txBox="1"/>
+          <p:nvPr/>
+        </p:nvSpPr>
+        <p:spPr>
+          <a:xfrm>
+            <a:off x="8805672" y="2783434"/>
+            <a:ext cx="2672791" cy="925373"/>
+          </a:xfrm>
+          <a:prstGeom prst="rect">
+            <a:avLst/>
+          </a:prstGeom>
+          <a:noFill/>
+          <a:ln/>
+        </p:spPr>
+        <p:txBody>
+          <a:bodyPr wrap="square" lIns="0" tIns="0" rIns="0" bIns="0" rtlCol="0" anchor="t"/>
+          <a:lstStyle/>
+          <a:p>
+            <a:pPr indent="0" marL="0">
+              <a:spcAft>
+                <a:spcPts val="400"/>
+              </a:spcAft>
+              <a:buNone/>
+            </a:pPr>
+            <a:r>
+              <a:rPr lang="en-US" sz="1550" b="1" dirty="0">
+                <a:solidFill>
+                  <a:schemeClr val="accent1"/>
+                </a:solidFill>
+              </a:rPr>
+              <a:t>Rozhodnutí</a:t>
+            </a:r>
+            <a:endParaRPr lang="en-US" sz="1550" dirty="0"/>
+          </a:p>
+          <a:p>
+            <a:pPr indent="0" marL="0">
+              <a:buNone/>
+            </a:pPr>
+            <a:r>
+              <a:rPr lang="en-US" sz="1250" dirty="0">
+                <a:solidFill>
+                  <a:schemeClr val="tx1"/>
+                </a:solidFill>
+              </a:rPr>
+              <a:t>τ × zdravotní přínos − náklad, v mezích rozpočtu, kapacit a rovnosti</a:t>
+            </a:r>
+            <a:endParaRPr lang="en-US" sz="1550" dirty="0"/>
+          </a:p>
+        </p:txBody>
+      </p:sp>
+      <p:sp>
+        <p:nvSpPr>
+          <p:cNvPr id="13" name="sip_ebm"/>
+          <p:cNvSpPr/>
+          <p:nvPr/>
+        </p:nvSpPr>
+        <p:spPr>
+          <a:xfrm>
+            <a:off x="3291840" y="1828800"/>
+            <a:ext cx="594360" cy="0"/>
+          </a:xfrm>
+          <a:prstGeom prst="line">
+            <a:avLst/>
+          </a:prstGeom>
+          <a:noFill/>
+          <a:ln w="25400">
+            <a:solidFill>
+              <a:srgbClr val="3D4F5C"/>
+            </a:solidFill>
+            <a:prstDash val="solid"/>
+            <a:tailEnd type="triangle"/>
+          </a:ln>
+        </p:spPr>
+      </p:sp>
+      <p:sp>
+        <p:nvSpPr>
+          <p:cNvPr id="14" name="sip_lit"/>
+          <p:cNvSpPr/>
+          <p:nvPr/>
+        </p:nvSpPr>
+        <p:spPr>
+          <a:xfrm>
+            <a:off x="3291840" y="3246120"/>
+            <a:ext cx="594360" cy="0"/>
+          </a:xfrm>
+          <a:prstGeom prst="line">
+            <a:avLst/>
+          </a:prstGeom>
+          <a:noFill/>
+          <a:ln w="25400">
+            <a:solidFill>
+              <a:srgbClr val="3D4F5C"/>
+            </a:solidFill>
+            <a:prstDash val="solid"/>
+            <a:tailEnd type="triangle"/>
+          </a:ln>
+        </p:spPr>
+      </p:sp>
+      <p:sp>
+        <p:nvSpPr>
+          <p:cNvPr id="15" name="sip_exp"/>
+          <p:cNvSpPr/>
+          <p:nvPr/>
+        </p:nvSpPr>
+        <p:spPr>
+          <a:xfrm>
+            <a:off x="8046720" y="1828800"/>
+            <a:ext cx="594360" cy="0"/>
+          </a:xfrm>
+          <a:prstGeom prst="line">
+            <a:avLst/>
+          </a:prstGeom>
+          <a:noFill/>
+          <a:ln w="25400">
+            <a:solidFill>
+              <a:srgbClr val="3D4F5C"/>
+            </a:solidFill>
+            <a:prstDash val="solid"/>
+            <a:headEnd type="triangle"/>
+          </a:ln>
+        </p:spPr>
+      </p:sp>
+      <p:sp>
+        <p:nvSpPr>
+          <p:cNvPr id="16" name="sip_rozh"/>
+          <p:cNvSpPr/>
+          <p:nvPr/>
+        </p:nvSpPr>
+        <p:spPr>
+          <a:xfrm>
+            <a:off x="8046720" y="3246120"/>
+            <a:ext cx="594360" cy="0"/>
+          </a:xfrm>
+          <a:prstGeom prst="line">
+            <a:avLst/>
+          </a:prstGeom>
+          <a:noFill/>
+          <a:ln w="25400">
+            <a:solidFill>
+              <a:srgbClr val="3D4F5C"/>
+            </a:solidFill>
+            <a:prstDash val="solid"/>
+            <a:tailEnd type="triangle"/>
+          </a:ln>
+        </p:spPr>
+      </p:sp>
+      <p:sp>
+        <p:nvSpPr>
+          <p:cNvPr id="17" name="sip_pruzkum"/>
+          <p:cNvSpPr/>
+          <p:nvPr/>
+        </p:nvSpPr>
+        <p:spPr>
+          <a:xfrm>
+            <a:off x="10142068" y="2423160"/>
+            <a:ext cx="0" cy="228600"/>
+          </a:xfrm>
+          <a:prstGeom prst="line">
+            <a:avLst/>
+          </a:prstGeom>
+          <a:noFill/>
+          <a:ln w="25400">
+            <a:solidFill>
+              <a:srgbClr val="3D4F5C"/>
+            </a:solidFill>
+            <a:prstDash val="solid"/>
+            <a:headEnd type="triangle"/>
+          </a:ln>
+        </p:spPr>
+      </p:sp>
+      <p:sp>
+        <p:nvSpPr>
+          <p:cNvPr id="18" name="sip_pruzkum_popis"/>
+          <p:cNvSpPr txBox="1"/>
+          <p:nvPr/>
+        </p:nvSpPr>
+        <p:spPr>
+          <a:xfrm>
+            <a:off x="10233508" y="2400300"/>
+            <a:ext cx="1463040" cy="274320"/>
+          </a:xfrm>
+          <a:prstGeom prst="rect">
+            <a:avLst/>
+          </a:prstGeom>
+          <a:noFill/>
+          <a:ln/>
+        </p:spPr>
+        <p:txBody>
+          <a:bodyPr wrap="square" lIns="0" tIns="0" rIns="0" bIns="0" rtlCol="0" anchor="t"/>
+          <a:lstStyle/>
+          <a:p>
+            <a:pPr indent="0" marL="0">
+              <a:buNone/>
+            </a:pPr>
+            <a:r>
+              <a:rPr lang="en-US" sz="1100" i="1" dirty="0">
+                <a:solidFill>
+                  <a:schemeClr val="accent4"/>
+                </a:solidFill>
+              </a:rPr>
+              <a:t>průzkum ~10 %</a:t>
+            </a:r>
+            <a:endParaRPr lang="en-US" sz="1100" dirty="0"/>
+          </a:p>
+        </p:txBody>
+      </p:sp>
+      <p:sp>
+        <p:nvSpPr>
+          <p:cNvPr id="19" name="pozdeji"/>
+          <p:cNvSpPr/>
+          <p:nvPr/>
+        </p:nvSpPr>
+        <p:spPr>
+          <a:xfrm>
+            <a:off x="3886200" y="4023360"/>
+            <a:ext cx="4160520" cy="502920"/>
+          </a:xfrm>
+          <a:prstGeom prst="roundRect">
+            <a:avLst>
+              <a:gd name="adj" fmla="val 14545"/>
+            </a:avLst>
+          </a:prstGeom>
+          <a:solidFill>
+            <a:schemeClr val="bg1"/>
+          </a:solidFill>
+          <a:ln w="12700">
+            <a:solidFill>
+              <a:srgbClr val="3D4F5C"/>
+            </a:solidFill>
+            <a:prstDash val="dash"/>
+          </a:ln>
+        </p:spPr>
+      </p:sp>
+      <p:sp>
+        <p:nvSpPr>
+          <p:cNvPr id="20" name="pozdeji_text"/>
+          <p:cNvSpPr txBox="1"/>
+          <p:nvPr/>
+        </p:nvSpPr>
+        <p:spPr>
+          <a:xfrm>
+            <a:off x="4023360" y="4096512"/>
+            <a:ext cx="3886200" cy="365760"/>
+          </a:xfrm>
+          <a:prstGeom prst="rect">
+            <a:avLst/>
+          </a:prstGeom>
+          <a:noFill/>
+          <a:ln/>
+        </p:spPr>
+        <p:txBody>
+          <a:bodyPr wrap="square" lIns="0" tIns="0" rIns="0" bIns="0" rtlCol="0" anchor="ctr"/>
+          <a:lstStyle/>
+          <a:p>
+            <a:pPr indent="0" marL="0">
+              <a:buNone/>
+            </a:pPr>
+            <a:r>
+              <a:rPr lang="en-US" sz="1200" b="1" dirty="0">
+                <a:solidFill>
+                  <a:schemeClr val="accent4"/>
+                </a:solidFill>
+              </a:rPr>
+              <a:t>Později, s dostatkem dat:</a:t>
+            </a:r>
+            <a:r>
+              <a:rPr lang="en-US" sz="1200" dirty="0">
+                <a:solidFill>
+                  <a:schemeClr val="accent4"/>
+                </a:solidFill>
+              </a:rPr>
+              <a:t> DR-learner + causal forest</a:t>
+            </a:r>
+            <a:endParaRPr lang="en-US" sz="1200" dirty="0"/>
+          </a:p>
+        </p:txBody>
+      </p:sp>
+      <p:sp>
+        <p:nvSpPr>
+          <p:cNvPr id="21" name="proc_randomizace"/>
+          <p:cNvSpPr/>
+          <p:nvPr/>
+        </p:nvSpPr>
+        <p:spPr>
+          <a:xfrm>
+            <a:off x="548640" y="4754880"/>
+            <a:ext cx="3545738" cy="1600200"/>
+          </a:xfrm>
+          <a:prstGeom prst="roundRect">
+            <a:avLst>
+              <a:gd name="adj" fmla="val 4571"/>
+            </a:avLst>
+          </a:prstGeom>
+          <a:solidFill>
+            <a:schemeClr val="bg2"/>
+          </a:solidFill>
+          <a:ln/>
+        </p:spPr>
+      </p:sp>
+      <p:sp>
+        <p:nvSpPr>
+          <p:cNvPr id="22" name="proc_randomizace_text"/>
+          <p:cNvSpPr txBox="1"/>
+          <p:nvPr/>
+        </p:nvSpPr>
+        <p:spPr>
+          <a:xfrm>
+            <a:off x="713232" y="4886554"/>
+            <a:ext cx="3216554" cy="1336853"/>
+          </a:xfrm>
+          <a:prstGeom prst="rect">
+            <a:avLst/>
+          </a:prstGeom>
+          <a:noFill/>
+          <a:ln/>
+        </p:spPr>
+        <p:txBody>
+          <a:bodyPr wrap="square" lIns="0" tIns="0" rIns="0" bIns="0" rtlCol="0" anchor="t"/>
+          <a:lstStyle/>
+          <a:p>
+            <a:pPr indent="0" marL="0">
+              <a:spcAft>
+                <a:spcPts val="400"/>
+              </a:spcAft>
+              <a:buNone/>
+            </a:pPr>
+            <a:r>
+              <a:rPr lang="en-US" sz="1550" b="1" dirty="0">
+                <a:solidFill>
+                  <a:schemeClr val="accent1"/>
+                </a:solidFill>
+              </a:rPr>
+              <a:t>Proč randomizace</a:t>
+            </a:r>
+            <a:endParaRPr lang="en-US" sz="1550" dirty="0"/>
+          </a:p>
+          <a:p>
+            <a:pPr indent="0" marL="0">
+              <a:buNone/>
+            </a:pPr>
+            <a:r>
+              <a:rPr lang="en-US" sz="1250" dirty="0">
+                <a:solidFill>
+                  <a:schemeClr val="tx1"/>
+                </a:solidFill>
+              </a:rPr>
+              <a:t>Data VZP ukážou, </a:t>
+            </a:r>
+            <a:r>
+              <a:rPr lang="en-US" sz="1250" b="1" dirty="0">
+                <a:solidFill>
+                  <a:schemeClr val="tx1"/>
+                </a:solidFill>
+              </a:rPr>
+              <a:t>kdo přichází</a:t>
+            </a:r>
+            <a:r>
+              <a:rPr lang="en-US" sz="1250" dirty="0">
+                <a:solidFill>
+                  <a:schemeClr val="tx1"/>
+                </a:solidFill>
+              </a:rPr>
+              <a:t>, ale ne </a:t>
+            </a:r>
+            <a:r>
+              <a:rPr lang="en-US" sz="1250" b="1" dirty="0">
+                <a:solidFill>
+                  <a:schemeClr val="tx1"/>
+                </a:solidFill>
+              </a:rPr>
+              <a:t>kdo přijde díky intervenci</a:t>
+            </a:r>
+            <a:r>
+              <a:rPr lang="en-US" sz="1250" dirty="0">
+                <a:solidFill>
+                  <a:schemeClr val="tx1"/>
+                </a:solidFill>
+              </a:rPr>
+              <a:t>: kanály nikdy nebyly přidělené náhodně. Uplift se proto učí z pokusů.</a:t>
+            </a:r>
+            <a:endParaRPr lang="en-US" sz="1550" dirty="0"/>
+          </a:p>
+        </p:txBody>
+      </p:sp>
+      <p:sp>
+        <p:nvSpPr>
+          <p:cNvPr id="23" name="vyhodnoceni"/>
+          <p:cNvSpPr/>
+          <p:nvPr/>
+        </p:nvSpPr>
+        <p:spPr>
+          <a:xfrm>
+            <a:off x="4322978" y="4754880"/>
+            <a:ext cx="3545738" cy="1600200"/>
+          </a:xfrm>
+          <a:prstGeom prst="roundRect">
+            <a:avLst>
+              <a:gd name="adj" fmla="val 4571"/>
+            </a:avLst>
+          </a:prstGeom>
+          <a:solidFill>
+            <a:schemeClr val="bg2"/>
+          </a:solidFill>
+          <a:ln/>
+        </p:spPr>
+      </p:sp>
+      <p:sp>
+        <p:nvSpPr>
+          <p:cNvPr id="24" name="vyhodnoceni_text"/>
+          <p:cNvSpPr txBox="1"/>
+          <p:nvPr/>
+        </p:nvSpPr>
+        <p:spPr>
+          <a:xfrm>
+            <a:off x="4487570" y="4886554"/>
+            <a:ext cx="3216554" cy="1336853"/>
+          </a:xfrm>
+          <a:prstGeom prst="rect">
+            <a:avLst/>
+          </a:prstGeom>
+          <a:noFill/>
+          <a:ln/>
+        </p:spPr>
+        <p:txBody>
+          <a:bodyPr wrap="square" lIns="0" tIns="0" rIns="0" bIns="0" rtlCol="0" anchor="t"/>
+          <a:lstStyle/>
+          <a:p>
+            <a:pPr indent="0" marL="0">
+              <a:spcAft>
+                <a:spcPts val="400"/>
+              </a:spcAft>
+              <a:buNone/>
+            </a:pPr>
+            <a:r>
+              <a:rPr lang="en-US" sz="1550" b="1" dirty="0">
+                <a:solidFill>
+                  <a:schemeClr val="accent1"/>
+                </a:solidFill>
+              </a:rPr>
+              <a:t>Vyhodnocení</a:t>
+            </a:r>
+            <a:endParaRPr lang="en-US" sz="1550" dirty="0"/>
+          </a:p>
+          <a:p>
+            <a:pPr indent="0" marL="0">
+              <a:buNone/>
+            </a:pPr>
+            <a:r>
+              <a:rPr lang="en-US" sz="1250" dirty="0">
+                <a:solidFill>
+                  <a:schemeClr val="tx1"/>
+                </a:solidFill>
+              </a:rPr>
+              <a:t>Qini / AUUC a kalibrace upliftu po decilech, hodnota pravidla cílení off-policy (DR), </a:t>
+            </a:r>
+            <a:r>
+              <a:rPr lang="en-US" sz="1250" b="1" dirty="0">
+                <a:solidFill>
+                  <a:schemeClr val="tx1"/>
+                </a:solidFill>
+              </a:rPr>
+              <a:t>trvalá kontrolní skupina</a:t>
+            </a:r>
+            <a:r>
+              <a:rPr lang="en-US" sz="1250" dirty="0">
+                <a:solidFill>
+                  <a:schemeClr val="tx1"/>
+                </a:solidFill>
+              </a:rPr>
+              <a:t>.</a:t>
+            </a:r>
+            <a:endParaRPr lang="en-US" sz="1550" dirty="0"/>
+          </a:p>
+        </p:txBody>
+      </p:sp>
+      <p:sp>
+        <p:nvSpPr>
+          <p:cNvPr id="25" name="rizika"/>
+          <p:cNvSpPr/>
+          <p:nvPr/>
+        </p:nvSpPr>
+        <p:spPr>
+          <a:xfrm>
+            <a:off x="8097317" y="4754880"/>
+            <a:ext cx="3545738" cy="1600200"/>
+          </a:xfrm>
+          <a:prstGeom prst="roundRect">
+            <a:avLst>
+              <a:gd name="adj" fmla="val 4571"/>
+            </a:avLst>
+          </a:prstGeom>
+          <a:solidFill>
+            <a:schemeClr val="bg2"/>
+          </a:solidFill>
+          <a:ln/>
+        </p:spPr>
+      </p:sp>
+      <p:sp>
+        <p:nvSpPr>
+          <p:cNvPr id="26" name="rizika_text"/>
+          <p:cNvSpPr txBox="1"/>
+          <p:nvPr/>
+        </p:nvSpPr>
+        <p:spPr>
+          <a:xfrm>
+            <a:off x="8261909" y="4886554"/>
+            <a:ext cx="3216554" cy="1336853"/>
+          </a:xfrm>
+          <a:prstGeom prst="rect">
+            <a:avLst/>
+          </a:prstGeom>
+          <a:noFill/>
+          <a:ln/>
+        </p:spPr>
+        <p:txBody>
+          <a:bodyPr wrap="square" lIns="0" tIns="0" rIns="0" bIns="0" rtlCol="0" anchor="t"/>
+          <a:lstStyle/>
+          <a:p>
+            <a:pPr indent="0" marL="0">
+              <a:spcAft>
+                <a:spcPts val="400"/>
+              </a:spcAft>
+              <a:buNone/>
+            </a:pPr>
+            <a:r>
+              <a:rPr lang="en-US" sz="1550" b="1" dirty="0">
+                <a:solidFill>
+                  <a:schemeClr val="accent1"/>
+                </a:solidFill>
+              </a:rPr>
+              <a:t>Rizika</a:t>
+            </a:r>
+            <a:endParaRPr lang="en-US" sz="1550" dirty="0"/>
+          </a:p>
+          <a:p>
+            <a:pPr indent="0" marL="0">
+              <a:buNone/>
+            </a:pPr>
+            <a:r>
+              <a:rPr lang="en-US" sz="1250" dirty="0">
+                <a:solidFill>
+                  <a:schemeClr val="tx1"/>
+                </a:solidFill>
+              </a:rPr>
+              <a:t>Negativní uplift („sleeping dogs“), pořadí kanálů (dopis → SMS → telefonát), posun v čase, férovost.</a:t>
+            </a:r>
+            <a:endParaRPr lang="en-US" sz="1550" dirty="0"/>
+          </a:p>
+        </p:txBody>
+      </p:sp>
+      <p:sp>
+        <p:nvSpPr>
+          <p:cNvPr id="25" name="Slide Number Placeholder 0"/>
+          <p:cNvSpPr>
+            <a:spLocks noGrp="1"/>
+          </p:cNvSpPr>
+          <p:nvPr>
+            <p:ph type="sldNum" sz="quarter" idx="4294967295"/>
+          </p:nvPr>
+        </p:nvSpPr>
+        <p:spPr>
+          <a:xfrm>
+            <a:off x="11094415" y="6446520"/>
+            <a:ext cx="548640" cy="274320"/>
+          </a:xfrm>
+          <a:prstGeom prst="rect">
+            <a:avLst/>
+          </a:prstGeom>
+          <a:extLst>
+            <a:ext uri="{C572A759-6A51-4108-AA02-DFA0A04FC94B}">
+              <ma14:wrappingTextBoxFlag xmlns:ma14="http://schemas.microsoft.com/office/mac/drawingml/2011/main" val="0"/>
+            </a:ext>
+          </a:extLst>
+        </p:spPr>
+        <p:txBody>
+          <a:bodyPr/>
+          <a:lstStyle>
+            <a:lvl1pPr>
+              <a:defRPr sz="1000">
+                <a:solidFill>
+                  <a:schemeClr val="accent4"/>
+                </a:solidFill>
+              </a:defRPr>
+            </a:lvl1pPr>
+          </a:lstStyle>
+          <a:p>
+            <a:pPr algn="r"/>
+            <a:fld id="{F7021451-1387-4CA6-816F-3879F97B5CBC}" type="slidenum">
+              <a:rPr b="0" lang="en-US"/>
+              <a:t>5</a:t>
+            </a:fld>
+            <a:endParaRPr lang="en-US"/>
+          </a:p>
+        </p:txBody>
+      </p:sp>
+    </p:spTree>
+  </p:cSld>
+  <p:clrMapOvr>
+    <a:masterClrMapping/>
+  </p:clrMapOvr>
+</p:sld>
+</file>
+
+<file path=ppt/slides/slide6.xml><?xml version="1.0" encoding="utf-8"?>
+<p:sld xmlns:a="http://schemas.openxmlformats.org/drawingml/2006/main" xmlns:r="http://schemas.openxmlformats.org/officeDocument/2006/relationships" xmlns:p="http://schemas.openxmlformats.org/presentationml/2006/main">
+  <p:cSld name="Slide 6">
+    <p:spTree>
+      <p:nvGrpSpPr>
+        <p:cNvPr id="1" name=""/>
+        <p:cNvGrpSpPr/>
+        <p:nvPr/>
+      </p:nvGrpSpPr>
+      <p:grpSpPr>
+        <a:xfrm>
+          <a:off x="0" y="0"/>
+          <a:ext cx="0" cy="0"/>
+          <a:chOff x="0" y="0"/>
+          <a:chExt cx="0" cy="0"/>
+        </a:xfrm>
+      </p:grpSpPr>
+      <p:sp>
+        <p:nvSpPr>
+          <p:cNvPr id="2" name="Text 0"/>
+          <p:cNvSpPr/>
+          <p:nvPr>
+            <p:ph idx="100" type="title" hasCustomPrompt="1"/>
+          </p:nvPr>
+        </p:nvSpPr>
+        <p:spPr>
+          <a:xfrm>
+            <a:off x="548640" y="320040"/>
+            <a:ext cx="11094415" cy="731520"/>
+          </a:xfrm>
+          <a:prstGeom prst="rect">
+            <a:avLst/>
+          </a:prstGeom>
+          <a:noFill/>
+          <a:ln/>
+        </p:spPr>
+        <p:txBody>
+          <a:bodyPr wrap="square" lIns="0" tIns="0" rIns="0" bIns="0" rtlCol="0" anchor="ctr"/>
+          <a:lstStyle/>
+          <a:p>
+            <a:pPr algn="l" indent="0" marL="0">
+              <a:buNone/>
+            </a:pPr>
+            <a:r>
+              <a:rPr lang="en-US" sz="3000" b="1" dirty="0">
+                <a:solidFill>
                   <a:schemeClr val="bg1"/>
                 </a:solidFill>
               </a:rPr>
@@ -6337,7 +7338,7 @@
                   <a:schemeClr val="accent3"/>
                 </a:solidFill>
               </a:rPr>
-              <a:t>víceramenná RCT po segmentech, zaznamenané pravděpodobnosti přiřazení</a:t>
+              <a:t>víceramenná RCT po segmentech, levně i v aplikaci VZP, zaznamenané pravděpodobnosti přiřazení</a:t>
             </a:r>
             <a:endParaRPr lang="en-US" sz="1700" dirty="0"/>
           </a:p>
@@ -6906,7 +7907,7 @@
             <a:pPr algn="r"/>
             <a:fld id="{F7021451-1387-4CA6-816F-3879F97B5CBC}" type="slidenum">
               <a:rPr b="0" lang="en-US"/>
-              <a:t>5</a:t>
+              <a:t>6</a:t>
             </a:fld>
             <a:endParaRPr lang="en-US"/>
           </a:p>

</xml_diff>